<commit_message>
Day 2: scripting labs, cheat sheets, afternoon restructured around the TPs
- Add Cheatsheets/: Linux basics, Bash scripting, Kali/OSINT tools (md + pdf).
- Add Day 2 scripting labs: Email Harvester (bash/curl/regex, recursive) and API Scraping (Burp + Python).
- Rework the Day 2 deck's afternoon into a TP red thread (toolbox -> Geosint -> media forensics) with clear per-TP markers; morning theory unchanged.
</commit_message>
<xml_diff>
--- a/Day_2/Day_2_Source_Reliability_And_Media_Forensics.pptx
+++ b/Day_2/Day_2_Source_Reliability_And_Media_Forensics.pptx
@@ -35,6 +35,7 @@
     <p:sldId id="283" r:id="rId34"/>
     <p:sldId id="284" r:id="rId35"/>
     <p:sldId id="285" r:id="rId36"/>
+    <p:sldId id="288" r:id="rId39"/>
     <p:sldId id="286" r:id="rId37"/>
     <p:sldId id="287" r:id="rId38"/>
   </p:sldIdLst>
@@ -16260,7 +16261,7 @@
                 </a:solidFill>
                 <a:latin typeface="Arial"/>
               </a:rPr>
-              <a:t>Authenticate &amp; dismantle</a:t>
+              <a:t>From toolbox to verdict</a:t>
             </a:r>
           </a:p>
         </p:txBody>
@@ -16507,7 +16508,7 @@
                 </a:solidFill>
                 <a:latin typeface="Arial"/>
               </a:rPr>
-              <a:t>Afternoon workshops</a:t>
+              <a:t>Afternoon red thread</a:t>
             </a:r>
           </a:p>
         </p:txBody>
@@ -16659,7 +16660,7 @@
                 </a:solidFill>
                 <a:latin typeface="Arial"/>
               </a:rPr>
-              <a:t>Five workshops, from file to campaign.</a:t>
+              <a:t>Four hands-on TPs, in order. Each applies this morning's theory; the cheat sheets are your toolbox.</a:t>
             </a:r>
           </a:p>
         </p:txBody>
@@ -16699,7 +16700,7 @@
                           </a:solidFill>
                           <a:latin typeface="Arial"/>
                         </a:rPr>
-                        <a:t>Session</a:t>
+                        <a:t>Step</a:t>
                       </a:r>
                     </a:p>
                   </a:txBody>
@@ -16722,7 +16723,7 @@
                           </a:solidFill>
                           <a:latin typeface="Arial"/>
                         </a:rPr>
-                        <a:t>Topic</a:t>
+                        <a:t>Hands-on TP</a:t>
                       </a:r>
                     </a:p>
                   </a:txBody>
@@ -16770,7 +16771,7 @@
                           </a:solidFill>
                           <a:latin typeface="Arial"/>
                         </a:rPr>
-                        <a:t>A</a:t>
+                        <a:t>1</a:t>
                       </a:r>
                     </a:p>
                   </a:txBody>
@@ -16793,7 +16794,7 @@
                           </a:solidFill>
                           <a:latin typeface="Arial"/>
                         </a:rPr>
-                        <a:t>Metadata &amp; structure (exiftool, thumbnail)</a:t>
+                        <a:t>Scripting toolbox - Email Harvester (curl+regex) + API Scraping (Burp+Python)</a:t>
                       </a:r>
                     </a:p>
                   </a:txBody>
@@ -16816,7 +16817,7 @@
                           </a:solidFill>
                           <a:latin typeface="Arial"/>
                         </a:rPr>
-                        <a:t>30 min</a:t>
+                        <a:t>90 min</a:t>
                       </a:r>
                     </a:p>
                   </a:txBody>
@@ -16841,7 +16842,7 @@
                           </a:solidFill>
                           <a:latin typeface="Arial"/>
                         </a:rPr>
-                        <a:t>B</a:t>
+                        <a:t>2</a:t>
                       </a:r>
                     </a:p>
                   </a:txBody>
@@ -16864,7 +16865,7 @@
                           </a:solidFill>
                           <a:latin typeface="Arial"/>
                         </a:rPr>
-                        <a:t>Signal: ELA + physical coherence (shadows)</a:t>
+                        <a:t>Geosint - Operation Glass Eye (geolocation &amp; chronolocation)</a:t>
                       </a:r>
                     </a:p>
                   </a:txBody>
@@ -16887,7 +16888,7 @@
                           </a:solidFill>
                           <a:latin typeface="Arial"/>
                         </a:rPr>
-                        <a:t>40 min</a:t>
+                        <a:t>75 min</a:t>
                       </a:r>
                     </a:p>
                   </a:txBody>
@@ -16912,7 +16913,7 @@
                           </a:solidFill>
                           <a:latin typeface="Arial"/>
                         </a:rPr>
-                        <a:t>C</a:t>
+                        <a:t>3</a:t>
                       </a:r>
                     </a:p>
                   </a:txBody>
@@ -16935,7 +16936,7 @@
                           </a:solidFill>
                           <a:latin typeface="Arial"/>
                         </a:rPr>
-                        <a:t>Recontextualisation &amp; provenance (reverse, C2PA)</a:t>
+                        <a:t>Media Forensics - Operation Riverbank (authenticate &amp; dismantle)</a:t>
                       </a:r>
                     </a:p>
                   </a:txBody>
@@ -16958,7 +16959,7 @@
                           </a:solidFill>
                           <a:latin typeface="Arial"/>
                         </a:rPr>
-                        <a:t>35 min</a:t>
+                        <a:t>75 min</a:t>
                       </a:r>
                     </a:p>
                   </a:txBody>
@@ -16983,7 +16984,7 @@
                           </a:solidFill>
                           <a:latin typeface="Arial"/>
                         </a:rPr>
-                        <a:t>D</a:t>
+                        <a:t>Deliverable</a:t>
                       </a:r>
                     </a:p>
                   </a:txBody>
@@ -17006,7 +17007,7 @@
                           </a:solidFill>
                           <a:latin typeface="Arial"/>
                         </a:rPr>
-                        <a:t>Video forensics (keyframes, cuts)</a:t>
+                        <a:t>One verification note per case (verdict + provenance + rating)</a:t>
                       </a:r>
                     </a:p>
                   </a:txBody>
@@ -17029,7 +17030,7 @@
                           </a:solidFill>
                           <a:latin typeface="Arial"/>
                         </a:rPr>
-                        <a:t>35 min</a:t>
+                        <a:t>-</a:t>
                       </a:r>
                     </a:p>
                   </a:txBody>
@@ -17054,7 +17055,7 @@
                           </a:solidFill>
                           <a:latin typeface="Arial"/>
                         </a:rPr>
-                        <a:t>E</a:t>
+                        <a:t>Toolbox</a:t>
                       </a:r>
                     </a:p>
                   </a:txBody>
@@ -17077,7 +17078,7 @@
                           </a:solidFill>
                           <a:latin typeface="Arial"/>
                         </a:rPr>
-                        <a:t>Coordinated behaviour (CIB)</a:t>
+                        <a:t>Cheat sheets: Linux basics, Bash scripting, Kali/OSINT tools</a:t>
                       </a:r>
                     </a:p>
                   </a:txBody>
@@ -17100,7 +17101,7 @@
                           </a:solidFill>
                           <a:latin typeface="Arial"/>
                         </a:rPr>
-                        <a:t>40 min</a:t>
+                        <a:t>-</a:t>
                       </a:r>
                     </a:p>
                   </a:txBody>
@@ -17205,7 +17206,7 @@
                 </a:solidFill>
                 <a:latin typeface="Arial"/>
               </a:rPr>
-              <a:t>LAB — WORKSHOPS A/B</a:t>
+              <a:t>LAB - TP 1</a:t>
             </a:r>
           </a:p>
         </p:txBody>
@@ -17258,7 +17259,7 @@
                 </a:solidFill>
                 <a:latin typeface="Arial"/>
               </a:rPr>
-              <a:t>Authenticating an image</a:t>
+              <a:t>Build your toolbox (scripting)</a:t>
             </a:r>
           </a:p>
         </p:txBody>
@@ -17410,7 +17411,7 @@
                 </a:solidFill>
                 <a:latin typeface="Arial"/>
               </a:rPr>
-              <a:t>Critical metadata + ELA.</a:t>
+              <a:t>Harvest data with curl + regex, then scrape an API you captured with Burp + Python.</a:t>
             </a:r>
           </a:p>
         </p:txBody>
@@ -17512,7 +17513,7 @@
                 </a:solidFill>
                 <a:latin typeface="Consolas"/>
               </a:rPr>
-              <a:t># Metadata + sensitive fields</a:t>
+              <a:t># Recursive e-mail harvest (bash + curl + regex)</a:t>
             </a:r>
           </a:p>
           <a:p>
@@ -17529,7 +17530,7 @@
                 </a:solidFill>
                 <a:latin typeface="Consolas"/>
               </a:rPr>
-              <a:t>exiftool -a -G1 image.jpg</a:t>
+              <a:t>curl -sL "$URL" | grep -oE '[A-Za-z0-9._%+-]+@[A-Za-z0-9.-]+\.[A-Za-z]{2,}'</a:t>
             </a:r>
           </a:p>
           <a:p>
@@ -17546,7 +17547,7 @@
                 </a:solidFill>
                 <a:latin typeface="Consolas"/>
               </a:rPr>
-              <a:t>exiftool -GPS:All -DateTimeOriginal -Software -Model image.jpg</a:t>
+              <a:t>./harvest.sh http://target/ 2        # crawl depth 2  -&gt; emails.csv</a:t>
             </a:r>
           </a:p>
           <a:p>
@@ -17580,7 +17581,7 @@
                 </a:solidFill>
                 <a:latin typeface="Consolas"/>
               </a:rPr>
-              <a:t># Embedded thumbnail vs visible image (cropping/montage)</a:t>
+              <a:t># Replay a captured API request (python + requests)</a:t>
             </a:r>
           </a:p>
           <a:p>
@@ -17597,7 +17598,7 @@
                 </a:solidFill>
                 <a:latin typeface="Consolas"/>
               </a:rPr>
-              <a:t>exiftool -b -ThumbnailImage image.jpg &gt; thumb.jpg</a:t>
+              <a:t>r = session.get(url, headers={"Authorization": f"Bearer {token}"})</a:t>
             </a:r>
           </a:p>
           <a:p>
@@ -17614,41 +17615,7 @@
                 </a:solidFill>
                 <a:latin typeface="Consolas"/>
               </a:rPr>
-              <a:t/>
-            </a:r>
-          </a:p>
-          <a:p>
-            <a:pPr algn="l">
-              <a:lnSpc>
-                <a:spcPct val="102000"/>
-              </a:lnSpc>
-              <a:buNone/>
-            </a:pPr>
-            <a:r>
-              <a:rPr sz="1050" b="0" i="0">
-                <a:solidFill>
-                  <a:srgbClr val="6B7280"/>
-                </a:solidFill>
-                <a:latin typeface="Consolas"/>
-              </a:rPr>
-              <a:t># Custom ELA (Python): recompression + amplified difference</a:t>
-            </a:r>
-          </a:p>
-          <a:p>
-            <a:pPr algn="l">
-              <a:lnSpc>
-                <a:spcPct val="102000"/>
-              </a:lnSpc>
-              <a:buNone/>
-            </a:pPr>
-            <a:r>
-              <a:rPr sz="1050" b="0" i="0">
-                <a:solidFill>
-                  <a:srgbClr val="6B7280"/>
-                </a:solidFill>
-                <a:latin typeface="Consolas"/>
-              </a:rPr>
-              <a:t># PIL: ImageChops.difference(orig, recompressed)  -&gt; suspicious zones</a:t>
+              <a:t>df = pd.json_normalize(r.json()["hits"]); df.to_csv("products.csv")</a:t>
             </a:r>
           </a:p>
         </p:txBody>
@@ -17793,7 +17760,7 @@
                 </a:solidFill>
                 <a:latin typeface="Arial"/>
               </a:rPr>
-              <a:t>READ WITH CAUTION</a:t>
+              <a:t>CHEAT SHEETS</a:t>
             </a:r>
           </a:p>
         </p:txBody>
@@ -17846,7 +17813,7 @@
                 </a:solidFill>
                 <a:latin typeface="Arial"/>
               </a:rPr>
-              <a:t>Missing metadata ≠ fake; ELA is an indicator. Conclude by convergence.</a:t>
+              <a:t>Reference: Linux basics, Bash scripting, Kali/OSINT tools. Authorised targets only.</a:t>
             </a:r>
           </a:p>
         </p:txBody>
@@ -18621,7 +18588,7 @@
                 </a:solidFill>
                 <a:latin typeface="Arial"/>
               </a:rPr>
-              <a:t>LAB — WORKSHOP E</a:t>
+              <a:t>LAB - TP 2</a:t>
             </a:r>
           </a:p>
         </p:txBody>
@@ -18674,7 +18641,7 @@
                 </a:solidFill>
                 <a:latin typeface="Arial"/>
               </a:rPr>
-              <a:t>Detecting CIB (Python)</a:t>
+              <a:t>Geosint - Operation Glass Eye</a:t>
             </a:r>
           </a:p>
         </p:txBody>
@@ -18826,7 +18793,7 @@
                 </a:solidFill>
                 <a:latin typeface="Arial"/>
               </a:rPr>
-              <a:t>Synchronisation, bursts, duplication, then amplification graph.</a:t>
+              <a:t>Geolocate a drone's last transmitted frame, then chronolocate it with the sun.</a:t>
             </a:r>
           </a:p>
         </p:txBody>
@@ -18924,11 +18891,11 @@
             <a:r>
               <a:rPr sz="1050" b="0" i="0">
                 <a:solidFill>
-                  <a:srgbClr val="1F2937"/>
+                  <a:srgbClr val="6B7280"/>
                 </a:solidFill>
                 <a:latin typeface="Consolas"/>
               </a:rPr>
-              <a:t>import pandas as pd, difflib</a:t>
+              <a:t># Chain of custody first (Seq. 1)</a:t>
             </a:r>
           </a:p>
           <a:p>
@@ -18945,7 +18912,7 @@
                 </a:solidFill>
                 <a:latin typeface="Consolas"/>
               </a:rPr>
-              <a:t>df = pd.read_csv("accounts.csv")</a:t>
+              <a:t>sha256sum last_frame.jpg ; exiftool -a -G1 last_frame.jpg</a:t>
             </a:r>
           </a:p>
           <a:p>
@@ -18962,7 +18929,7 @@
                 </a:solidFill>
                 <a:latin typeface="Consolas"/>
               </a:rPr>
-              <a:t>df["ts"] = pd.to_datetime(df["timestamp"], utc=True)</a:t>
+              <a:t/>
             </a:r>
           </a:p>
           <a:p>
@@ -18975,11 +18942,11 @@
             <a:r>
               <a:rPr sz="1050" b="0" i="0">
                 <a:solidFill>
-                  <a:srgbClr val="1F2937"/>
+                  <a:srgbClr val="6B7280"/>
                 </a:solidFill>
                 <a:latin typeface="Consolas"/>
               </a:rPr>
-              <a:t/>
+              <a:t># Enumerate candidates near the launch point (OpenStreetMap / Overpass)</a:t>
             </a:r>
           </a:p>
           <a:p>
@@ -18992,11 +18959,11 @@
             <a:r>
               <a:rPr sz="1050" b="0" i="0">
                 <a:solidFill>
-                  <a:srgbClr val="6B7280"/>
+                  <a:srgbClr val="1F2937"/>
                 </a:solidFill>
                 <a:latin typeface="Consolas"/>
               </a:rPr>
-              <a:t># Creation burst + post synchronisation</a:t>
+              <a:t>curl -s https://overpass-api.de/api/interpreter --data-urlencode \</a:t>
             </a:r>
           </a:p>
           <a:p>
@@ -19013,7 +18980,7 @@
                 </a:solidFill>
                 <a:latin typeface="Consolas"/>
               </a:rPr>
-              <a:t>df["creation_date"].value_counts().head()</a:t>
+              <a:t>  'data=[out:csv(::lat,::lon)];node["generator:source"="wind"](around:8000,47.5988,-1.1389);out;'</a:t>
             </a:r>
           </a:p>
           <a:p>
@@ -19030,7 +18997,7 @@
                 </a:solidFill>
                 <a:latin typeface="Consolas"/>
               </a:rPr>
-              <a:t>df.groupby(df["ts"].dt.floor("min")).size().sort_values(ascending=False).head()</a:t>
+              <a:t/>
             </a:r>
           </a:p>
           <a:p>
@@ -19043,45 +19010,11 @@
             <a:r>
               <a:rPr sz="1050" b="0" i="0">
                 <a:solidFill>
-                  <a:srgbClr val="1F2937"/>
+                  <a:srgbClr val="6B7280"/>
                 </a:solidFill>
                 <a:latin typeface="Consolas"/>
               </a:rPr>
-              <a:t/>
-            </a:r>
-          </a:p>
-          <a:p>
-            <a:pPr algn="l">
-              <a:lnSpc>
-                <a:spcPct val="102000"/>
-              </a:lnSpc>
-              <a:buNone/>
-            </a:pPr>
-            <a:r>
-              <a:rPr sz="1050" b="0" i="0">
-                <a:solidFill>
-                  <a:srgbClr val="6B7280"/>
-                </a:solidFill>
-                <a:latin typeface="Consolas"/>
-              </a:rPr>
-              <a:t># Near-duplicate text (similarity &gt; 0.85)</a:t>
-            </a:r>
-          </a:p>
-          <a:p>
-            <a:pPr algn="l">
-              <a:lnSpc>
-                <a:spcPct val="102000"/>
-              </a:lnSpc>
-              <a:buNone/>
-            </a:pPr>
-            <a:r>
-              <a:rPr sz="1050" b="0" i="0">
-                <a:solidFill>
-                  <a:srgbClr val="1F2937"/>
-                </a:solidFill>
-                <a:latin typeface="Consolas"/>
-              </a:rPr>
-              <a:t>difflib.SequenceMatcher(None, t_i, t_j).ratio()</a:t>
+              <a:t># Chronolocate: shadow direction + sun position  -&gt; SunCalc</a:t>
             </a:r>
           </a:p>
         </p:txBody>
@@ -19226,7 +19159,7 @@
                 </a:solidFill>
                 <a:latin typeface="Arial"/>
               </a:rPr>
-              <a:t>NEXT</a:t>
+              <a:t>APPLIES - Seq. 3</a:t>
             </a:r>
           </a:p>
         </p:txBody>
@@ -19279,7 +19212,7 @@
                 </a:solidFill>
                 <a:latin typeface="Arial"/>
               </a:rPr>
-              <a:t>Map the amplification network (Gephi/NetworkX): who starts it, who relays it.</a:t>
+              <a:t>Geolocation &amp; chronolocation. Rate every finding with the Admiralty scale.</a:t>
             </a:r>
           </a:p>
         </p:txBody>
@@ -20420,6 +20353,759 @@
                 <a:latin typeface="Arial"/>
               </a:rPr>
               <a:t>Day 3 — Dark web, crypto tracing &amp; endpoint forensics (memory analysis).</a:t>
+            </a:r>
+          </a:p>
+        </p:txBody>
+      </p:sp>
+    </p:spTree>
+  </p:cSld>
+  <p:clrMapOvr>
+    <a:masterClrMapping/>
+  </p:clrMapOvr>
+</p:sld>
+</file>
+
+<file path=ppt/slides/slide33.xml><?xml version="1.0" encoding="utf-8"?>
+<p:sld xmlns:a="http://schemas.openxmlformats.org/drawingml/2006/main" xmlns:p="http://schemas.openxmlformats.org/presentationml/2006/main" xmlns:r="http://schemas.openxmlformats.org/officeDocument/2006/relationships">
+  <p:cSld>
+    <p:spTree>
+      <p:nvGrpSpPr>
+        <p:cNvPr id="1" name=""/>
+        <p:cNvGrpSpPr/>
+        <p:nvPr/>
+      </p:nvGrpSpPr>
+      <p:grpSpPr/>
+      <p:pic>
+        <p:nvPicPr>
+          <p:cNvPr id="2" name="Picture 1" descr="ascent.png"/>
+          <p:cNvPicPr>
+            <a:picLocks noChangeAspect="1"/>
+          </p:cNvPicPr>
+          <p:nvPr/>
+        </p:nvPicPr>
+        <p:blipFill>
+          <a:blip r:embed="rId2"/>
+          <a:stretch>
+            <a:fillRect/>
+          </a:stretch>
+        </p:blipFill>
+        <p:spPr>
+          <a:xfrm>
+            <a:off x="8321040" y="228600"/>
+            <a:ext cx="502920" cy="502920"/>
+          </a:xfrm>
+          <a:prstGeom prst="rect">
+            <a:avLst/>
+          </a:prstGeom>
+        </p:spPr>
+      </p:pic>
+      <p:sp>
+        <p:nvSpPr>
+          <p:cNvPr id="3" name="Rectangle 2"/>
+          <p:cNvSpPr/>
+          <p:nvPr/>
+        </p:nvSpPr>
+        <p:spPr>
+          <a:xfrm>
+            <a:off x="457200" y="256032"/>
+            <a:ext cx="7669600" cy="228600"/>
+          </a:xfrm>
+          <a:prstGeom prst="rect">
+            <a:avLst/>
+          </a:prstGeom>
+          <a:noFill/>
+          <a:ln>
+            <a:noFill/>
+          </a:ln>
+          <a:effectLst/>
+        </p:spPr>
+        <p:style>
+          <a:lnRef idx="1">
+            <a:schemeClr val="accent1"/>
+          </a:lnRef>
+          <a:fillRef idx="3">
+            <a:schemeClr val="accent1"/>
+          </a:fillRef>
+          <a:effectRef idx="2">
+            <a:schemeClr val="accent1"/>
+          </a:effectRef>
+          <a:fontRef idx="minor">
+            <a:schemeClr val="lt1"/>
+          </a:fontRef>
+        </p:style>
+        <p:txBody>
+          <a:bodyPr rtlCol="0" anchor="ctr" lIns="0" tIns="0" rIns="0" bIns="0" wrap="square"/>
+          <a:lstStyle/>
+          <a:p>
+            <a:pPr algn="l">
+              <a:buNone/>
+            </a:pPr>
+            <a:r>
+              <a:rPr sz="1000" b="0" i="0">
+                <a:solidFill>
+                  <a:srgbClr val="6B7280"/>
+                </a:solidFill>
+                <a:latin typeface="Arial"/>
+              </a:rPr>
+              <a:t>LAB - TP 3</a:t>
+            </a:r>
+          </a:p>
+        </p:txBody>
+      </p:sp>
+      <p:sp>
+        <p:nvSpPr>
+          <p:cNvPr id="4" name="Rectangle 3"/>
+          <p:cNvSpPr/>
+          <p:nvPr/>
+        </p:nvSpPr>
+        <p:spPr>
+          <a:xfrm>
+            <a:off x="457200" y="475488"/>
+            <a:ext cx="8229600" cy="502920"/>
+          </a:xfrm>
+          <a:prstGeom prst="rect">
+            <a:avLst/>
+          </a:prstGeom>
+          <a:noFill/>
+          <a:ln>
+            <a:noFill/>
+          </a:ln>
+          <a:effectLst/>
+        </p:spPr>
+        <p:style>
+          <a:lnRef idx="1">
+            <a:schemeClr val="accent1"/>
+          </a:lnRef>
+          <a:fillRef idx="3">
+            <a:schemeClr val="accent1"/>
+          </a:fillRef>
+          <a:effectRef idx="2">
+            <a:schemeClr val="accent1"/>
+          </a:effectRef>
+          <a:fontRef idx="minor">
+            <a:schemeClr val="lt1"/>
+          </a:fontRef>
+        </p:style>
+        <p:txBody>
+          <a:bodyPr rtlCol="0" anchor="t" lIns="0" tIns="0" rIns="0" bIns="0" wrap="square"/>
+          <a:lstStyle/>
+          <a:p>
+            <a:pPr algn="l">
+              <a:buNone/>
+            </a:pPr>
+            <a:r>
+              <a:rPr sz="2200" b="1" i="0">
+                <a:solidFill>
+                  <a:srgbClr val="1F2937"/>
+                </a:solidFill>
+                <a:latin typeface="Arial"/>
+              </a:rPr>
+              <a:t>Media Forensics - Operation Riverbank</a:t>
+            </a:r>
+          </a:p>
+        </p:txBody>
+      </p:sp>
+      <p:sp>
+        <p:nvSpPr>
+          <p:cNvPr id="5" name="Rectangle 4"/>
+          <p:cNvSpPr/>
+          <p:nvPr/>
+        </p:nvSpPr>
+        <p:spPr>
+          <a:xfrm>
+            <a:off x="457200" y="1024128"/>
+            <a:ext cx="548640" cy="27432"/>
+          </a:xfrm>
+          <a:prstGeom prst="rect">
+            <a:avLst/>
+          </a:prstGeom>
+          <a:solidFill>
+            <a:srgbClr val="1E40AF"/>
+          </a:solidFill>
+          <a:ln w="12700">
+            <a:solidFill>
+              <a:srgbClr val="1E40AF"/>
+            </a:solidFill>
+          </a:ln>
+          <a:effectLst/>
+        </p:spPr>
+        <p:style>
+          <a:lnRef idx="1">
+            <a:schemeClr val="accent1"/>
+          </a:lnRef>
+          <a:fillRef idx="3">
+            <a:schemeClr val="accent1"/>
+          </a:fillRef>
+          <a:effectRef idx="2">
+            <a:schemeClr val="accent1"/>
+          </a:effectRef>
+          <a:fontRef idx="minor">
+            <a:schemeClr val="lt1"/>
+          </a:fontRef>
+        </p:style>
+        <p:txBody>
+          <a:bodyPr rtlCol="0" anchor="ctr"/>
+          <a:lstStyle/>
+          <a:p>
+            <a:pPr algn="ctr"/>
+          </a:p>
+        </p:txBody>
+      </p:sp>
+      <p:sp>
+        <p:nvSpPr>
+          <p:cNvPr id="6" name="Rectangle 5"/>
+          <p:cNvSpPr/>
+          <p:nvPr/>
+        </p:nvSpPr>
+        <p:spPr>
+          <a:xfrm>
+            <a:off x="457200" y="4823460"/>
+            <a:ext cx="4572000" cy="228600"/>
+          </a:xfrm>
+          <a:prstGeom prst="rect">
+            <a:avLst/>
+          </a:prstGeom>
+          <a:noFill/>
+          <a:ln>
+            <a:noFill/>
+          </a:ln>
+          <a:effectLst/>
+        </p:spPr>
+        <p:style>
+          <a:lnRef idx="1">
+            <a:schemeClr val="accent1"/>
+          </a:lnRef>
+          <a:fillRef idx="3">
+            <a:schemeClr val="accent1"/>
+          </a:fillRef>
+          <a:effectRef idx="2">
+            <a:schemeClr val="accent1"/>
+          </a:effectRef>
+          <a:fontRef idx="minor">
+            <a:schemeClr val="lt1"/>
+          </a:fontRef>
+        </p:style>
+        <p:txBody>
+          <a:bodyPr rtlCol="0" anchor="ctr" lIns="0" tIns="0" rIns="0" bIns="0" wrap="square"/>
+          <a:lstStyle/>
+          <a:p>
+            <a:pPr algn="l">
+              <a:buNone/>
+            </a:pPr>
+            <a:r>
+              <a:rPr sz="900" b="0" i="0">
+                <a:solidFill>
+                  <a:srgbClr val="6B7280"/>
+                </a:solidFill>
+                <a:latin typeface="Arial"/>
+              </a:rPr>
+              <a:t>Forensics &amp; OSINT Advanced  -  Day 2 / 3</a:t>
+            </a:r>
+          </a:p>
+        </p:txBody>
+      </p:sp>
+      <p:sp>
+        <p:nvSpPr>
+          <p:cNvPr id="7" name="Rectangle 6"/>
+          <p:cNvSpPr/>
+          <p:nvPr/>
+        </p:nvSpPr>
+        <p:spPr>
+          <a:xfrm>
+            <a:off x="457200" y="1188720"/>
+            <a:ext cx="8229600" cy="548640"/>
+          </a:xfrm>
+          <a:prstGeom prst="rect">
+            <a:avLst/>
+          </a:prstGeom>
+          <a:noFill/>
+          <a:ln>
+            <a:noFill/>
+          </a:ln>
+          <a:effectLst/>
+        </p:spPr>
+        <p:style>
+          <a:lnRef idx="1">
+            <a:schemeClr val="accent1"/>
+          </a:lnRef>
+          <a:fillRef idx="3">
+            <a:schemeClr val="accent1"/>
+          </a:fillRef>
+          <a:effectRef idx="2">
+            <a:schemeClr val="accent1"/>
+          </a:effectRef>
+          <a:fontRef idx="minor">
+            <a:schemeClr val="lt1"/>
+          </a:fontRef>
+        </p:style>
+        <p:txBody>
+          <a:bodyPr rtlCol="0" anchor="ctr" lIns="0" tIns="0" rIns="0" bIns="0" wrap="square"/>
+          <a:lstStyle/>
+          <a:p>
+            <a:pPr algn="l">
+              <a:buNone/>
+            </a:pPr>
+            <a:r>
+              <a:rPr sz="1300" b="0" i="1">
+                <a:solidFill>
+                  <a:srgbClr val="1F2937"/>
+                </a:solidFill>
+                <a:latin typeface="Arial"/>
+              </a:rPr>
+              <a:t>Authenticate &amp; dismantle a disinformation case: metadata, signal, provenance, video, coordination.</a:t>
+            </a:r>
+          </a:p>
+        </p:txBody>
+      </p:sp>
+      <p:sp>
+        <p:nvSpPr>
+          <p:cNvPr id="8" name="Rectangle 7"/>
+          <p:cNvSpPr/>
+          <p:nvPr/>
+        </p:nvSpPr>
+        <p:spPr>
+          <a:xfrm>
+            <a:off x="457200" y="1828800"/>
+            <a:ext cx="8229600" cy="2360000"/>
+          </a:xfrm>
+          <a:prstGeom prst="rect">
+            <a:avLst/>
+          </a:prstGeom>
+          <a:solidFill>
+            <a:srgbClr val="F9FAFB"/>
+          </a:solidFill>
+          <a:ln w="6350">
+            <a:solidFill>
+              <a:srgbClr val="E5E7EB"/>
+            </a:solidFill>
+          </a:ln>
+          <a:effectLst/>
+        </p:spPr>
+        <p:style>
+          <a:lnRef idx="1">
+            <a:schemeClr val="accent1"/>
+          </a:lnRef>
+          <a:fillRef idx="3">
+            <a:schemeClr val="accent1"/>
+          </a:fillRef>
+          <a:effectRef idx="2">
+            <a:schemeClr val="accent1"/>
+          </a:effectRef>
+          <a:fontRef idx="minor">
+            <a:schemeClr val="lt1"/>
+          </a:fontRef>
+        </p:style>
+        <p:txBody>
+          <a:bodyPr rtlCol="0" anchor="ctr"/>
+          <a:lstStyle/>
+          <a:p>
+            <a:pPr algn="ctr"/>
+          </a:p>
+        </p:txBody>
+      </p:sp>
+      <p:sp>
+        <p:nvSpPr>
+          <p:cNvPr id="9" name="Rectangle 8"/>
+          <p:cNvSpPr/>
+          <p:nvPr/>
+        </p:nvSpPr>
+        <p:spPr>
+          <a:xfrm>
+            <a:off x="594360" y="1920240"/>
+            <a:ext cx="7955280" cy="2177120"/>
+          </a:xfrm>
+          <a:prstGeom prst="rect">
+            <a:avLst/>
+          </a:prstGeom>
+          <a:noFill/>
+          <a:ln>
+            <a:noFill/>
+          </a:ln>
+          <a:effectLst/>
+        </p:spPr>
+        <p:style>
+          <a:lnRef idx="1">
+            <a:schemeClr val="accent1"/>
+          </a:lnRef>
+          <a:fillRef idx="3">
+            <a:schemeClr val="accent1"/>
+          </a:fillRef>
+          <a:effectRef idx="2">
+            <a:schemeClr val="accent1"/>
+          </a:effectRef>
+          <a:fontRef idx="minor">
+            <a:schemeClr val="lt1"/>
+          </a:fontRef>
+        </p:style>
+        <p:txBody>
+          <a:bodyPr rtlCol="0" anchor="t" lIns="0" tIns="0" rIns="0" bIns="0" wrap="square"/>
+          <a:lstStyle/>
+          <a:p>
+            <a:pPr algn="l">
+              <a:lnSpc>
+                <a:spcPct val="102000"/>
+              </a:lnSpc>
+              <a:buNone/>
+            </a:pPr>
+            <a:r>
+              <a:rPr sz="1050" b="0" i="0">
+                <a:solidFill>
+                  <a:srgbClr val="1F2937"/>
+                </a:solidFill>
+                <a:latin typeface="Consolas"/>
+              </a:rPr>
+              <a:t>import pandas as pd, difflib</a:t>
+            </a:r>
+          </a:p>
+          <a:p>
+            <a:pPr algn="l">
+              <a:lnSpc>
+                <a:spcPct val="102000"/>
+              </a:lnSpc>
+              <a:buNone/>
+            </a:pPr>
+            <a:r>
+              <a:rPr sz="1050" b="0" i="0">
+                <a:solidFill>
+                  <a:srgbClr val="1F2937"/>
+                </a:solidFill>
+                <a:latin typeface="Consolas"/>
+              </a:rPr>
+              <a:t>df = pd.read_csv("accounts.csv")</a:t>
+            </a:r>
+          </a:p>
+          <a:p>
+            <a:pPr algn="l">
+              <a:lnSpc>
+                <a:spcPct val="102000"/>
+              </a:lnSpc>
+              <a:buNone/>
+            </a:pPr>
+            <a:r>
+              <a:rPr sz="1050" b="0" i="0">
+                <a:solidFill>
+                  <a:srgbClr val="1F2937"/>
+                </a:solidFill>
+                <a:latin typeface="Consolas"/>
+              </a:rPr>
+              <a:t>df["ts"] = pd.to_datetime(df["timestamp"], utc=True)</a:t>
+            </a:r>
+          </a:p>
+          <a:p>
+            <a:pPr algn="l">
+              <a:lnSpc>
+                <a:spcPct val="102000"/>
+              </a:lnSpc>
+              <a:buNone/>
+            </a:pPr>
+            <a:r>
+              <a:rPr sz="1050" b="0" i="0">
+                <a:solidFill>
+                  <a:srgbClr val="1F2937"/>
+                </a:solidFill>
+                <a:latin typeface="Consolas"/>
+              </a:rPr>
+              <a:t/>
+            </a:r>
+          </a:p>
+          <a:p>
+            <a:pPr algn="l">
+              <a:lnSpc>
+                <a:spcPct val="102000"/>
+              </a:lnSpc>
+              <a:buNone/>
+            </a:pPr>
+            <a:r>
+              <a:rPr sz="1050" b="0" i="0">
+                <a:solidFill>
+                  <a:srgbClr val="6B7280"/>
+                </a:solidFill>
+                <a:latin typeface="Consolas"/>
+              </a:rPr>
+              <a:t># Creation burst + post synchronisation</a:t>
+            </a:r>
+          </a:p>
+          <a:p>
+            <a:pPr algn="l">
+              <a:lnSpc>
+                <a:spcPct val="102000"/>
+              </a:lnSpc>
+              <a:buNone/>
+            </a:pPr>
+            <a:r>
+              <a:rPr sz="1050" b="0" i="0">
+                <a:solidFill>
+                  <a:srgbClr val="1F2937"/>
+                </a:solidFill>
+                <a:latin typeface="Consolas"/>
+              </a:rPr>
+              <a:t>df["creation_date"].value_counts().head()</a:t>
+            </a:r>
+          </a:p>
+          <a:p>
+            <a:pPr algn="l">
+              <a:lnSpc>
+                <a:spcPct val="102000"/>
+              </a:lnSpc>
+              <a:buNone/>
+            </a:pPr>
+            <a:r>
+              <a:rPr sz="1050" b="0" i="0">
+                <a:solidFill>
+                  <a:srgbClr val="1F2937"/>
+                </a:solidFill>
+                <a:latin typeface="Consolas"/>
+              </a:rPr>
+              <a:t>df.groupby(df["ts"].dt.floor("min")).size().sort_values(ascending=False).head()</a:t>
+            </a:r>
+          </a:p>
+          <a:p>
+            <a:pPr algn="l">
+              <a:lnSpc>
+                <a:spcPct val="102000"/>
+              </a:lnSpc>
+              <a:buNone/>
+            </a:pPr>
+            <a:r>
+              <a:rPr sz="1050" b="0" i="0">
+                <a:solidFill>
+                  <a:srgbClr val="1F2937"/>
+                </a:solidFill>
+                <a:latin typeface="Consolas"/>
+              </a:rPr>
+              <a:t/>
+            </a:r>
+          </a:p>
+          <a:p>
+            <a:pPr algn="l">
+              <a:lnSpc>
+                <a:spcPct val="102000"/>
+              </a:lnSpc>
+              <a:buNone/>
+            </a:pPr>
+            <a:r>
+              <a:rPr sz="1050" b="0" i="0">
+                <a:solidFill>
+                  <a:srgbClr val="6B7280"/>
+                </a:solidFill>
+                <a:latin typeface="Consolas"/>
+              </a:rPr>
+              <a:t># Near-duplicate text (similarity &gt; 0.85)</a:t>
+            </a:r>
+          </a:p>
+          <a:p>
+            <a:pPr algn="l">
+              <a:lnSpc>
+                <a:spcPct val="102000"/>
+              </a:lnSpc>
+              <a:buNone/>
+            </a:pPr>
+            <a:r>
+              <a:rPr sz="1050" b="0" i="0">
+                <a:solidFill>
+                  <a:srgbClr val="1F2937"/>
+                </a:solidFill>
+                <a:latin typeface="Consolas"/>
+              </a:rPr>
+              <a:t>difflib.SequenceMatcher(None, t_i, t_j).ratio()</a:t>
+            </a:r>
+          </a:p>
+        </p:txBody>
+      </p:sp>
+      <p:sp>
+        <p:nvSpPr>
+          <p:cNvPr id="10" name="Rectangle 9"/>
+          <p:cNvSpPr/>
+          <p:nvPr/>
+        </p:nvSpPr>
+        <p:spPr>
+          <a:xfrm>
+            <a:off x="457200" y="4434840"/>
+            <a:ext cx="8229600" cy="411480"/>
+          </a:xfrm>
+          <a:prstGeom prst="rect">
+            <a:avLst/>
+          </a:prstGeom>
+          <a:solidFill>
+            <a:srgbClr val="F3F4F6"/>
+          </a:solidFill>
+          <a:ln w="12700">
+            <a:solidFill>
+              <a:srgbClr val="F3F4F6"/>
+            </a:solidFill>
+          </a:ln>
+          <a:effectLst/>
+        </p:spPr>
+        <p:style>
+          <a:lnRef idx="1">
+            <a:schemeClr val="accent1"/>
+          </a:lnRef>
+          <a:fillRef idx="3">
+            <a:schemeClr val="accent1"/>
+          </a:fillRef>
+          <a:effectRef idx="2">
+            <a:schemeClr val="accent1"/>
+          </a:effectRef>
+          <a:fontRef idx="minor">
+            <a:schemeClr val="lt1"/>
+          </a:fontRef>
+        </p:style>
+        <p:txBody>
+          <a:bodyPr rtlCol="0" anchor="ctr"/>
+          <a:lstStyle/>
+          <a:p>
+            <a:pPr algn="ctr"/>
+          </a:p>
+        </p:txBody>
+      </p:sp>
+      <p:sp>
+        <p:nvSpPr>
+          <p:cNvPr id="11" name="Rectangle 10"/>
+          <p:cNvSpPr/>
+          <p:nvPr/>
+        </p:nvSpPr>
+        <p:spPr>
+          <a:xfrm>
+            <a:off x="457200" y="4434840"/>
+            <a:ext cx="73152" cy="411480"/>
+          </a:xfrm>
+          <a:prstGeom prst="rect">
+            <a:avLst/>
+          </a:prstGeom>
+          <a:solidFill>
+            <a:srgbClr val="1E40AF"/>
+          </a:solidFill>
+          <a:ln w="12700">
+            <a:solidFill>
+              <a:srgbClr val="1E40AF"/>
+            </a:solidFill>
+          </a:ln>
+          <a:effectLst/>
+        </p:spPr>
+        <p:style>
+          <a:lnRef idx="1">
+            <a:schemeClr val="accent1"/>
+          </a:lnRef>
+          <a:fillRef idx="3">
+            <a:schemeClr val="accent1"/>
+          </a:fillRef>
+          <a:effectRef idx="2">
+            <a:schemeClr val="accent1"/>
+          </a:effectRef>
+          <a:fontRef idx="minor">
+            <a:schemeClr val="lt1"/>
+          </a:fontRef>
+        </p:style>
+        <p:txBody>
+          <a:bodyPr rtlCol="0" anchor="ctr"/>
+          <a:lstStyle/>
+          <a:p>
+            <a:pPr algn="ctr"/>
+          </a:p>
+        </p:txBody>
+      </p:sp>
+      <p:sp>
+        <p:nvSpPr>
+          <p:cNvPr id="12" name="Rectangle 11"/>
+          <p:cNvSpPr/>
+          <p:nvPr/>
+        </p:nvSpPr>
+        <p:spPr>
+          <a:xfrm>
+            <a:off x="640080" y="4464840"/>
+            <a:ext cx="7955280" cy="200000"/>
+          </a:xfrm>
+          <a:prstGeom prst="rect">
+            <a:avLst/>
+          </a:prstGeom>
+          <a:noFill/>
+          <a:ln>
+            <a:noFill/>
+          </a:ln>
+          <a:effectLst/>
+        </p:spPr>
+        <p:style>
+          <a:lnRef idx="1">
+            <a:schemeClr val="accent1"/>
+          </a:lnRef>
+          <a:fillRef idx="3">
+            <a:schemeClr val="accent1"/>
+          </a:fillRef>
+          <a:effectRef idx="2">
+            <a:schemeClr val="accent1"/>
+          </a:effectRef>
+          <a:fontRef idx="minor">
+            <a:schemeClr val="lt1"/>
+          </a:fontRef>
+        </p:style>
+        <p:txBody>
+          <a:bodyPr rtlCol="0" anchor="ctr" lIns="0" tIns="0" rIns="0" bIns="0" wrap="square"/>
+          <a:lstStyle/>
+          <a:p>
+            <a:pPr algn="l">
+              <a:buNone/>
+            </a:pPr>
+            <a:r>
+              <a:rPr sz="1000" b="1" i="0">
+                <a:solidFill>
+                  <a:srgbClr val="1E40AF"/>
+                </a:solidFill>
+                <a:latin typeface="Arial"/>
+              </a:rPr>
+              <a:t>WEIGHT OF EVIDENCE</a:t>
+            </a:r>
+          </a:p>
+        </p:txBody>
+      </p:sp>
+      <p:sp>
+        <p:nvSpPr>
+          <p:cNvPr id="13" name="Rectangle 12"/>
+          <p:cNvSpPr/>
+          <p:nvPr/>
+        </p:nvSpPr>
+        <p:spPr>
+          <a:xfrm>
+            <a:off x="640080" y="4644840"/>
+            <a:ext cx="7955280" cy="190000"/>
+          </a:xfrm>
+          <a:prstGeom prst="rect">
+            <a:avLst/>
+          </a:prstGeom>
+          <a:noFill/>
+          <a:ln>
+            <a:noFill/>
+          </a:ln>
+          <a:effectLst/>
+        </p:spPr>
+        <p:style>
+          <a:lnRef idx="1">
+            <a:schemeClr val="accent1"/>
+          </a:lnRef>
+          <a:fillRef idx="3">
+            <a:schemeClr val="accent1"/>
+          </a:fillRef>
+          <a:effectRef idx="2">
+            <a:schemeClr val="accent1"/>
+          </a:effectRef>
+          <a:fontRef idx="minor">
+            <a:schemeClr val="lt1"/>
+          </a:fontRef>
+        </p:style>
+        <p:txBody>
+          <a:bodyPr rtlCol="0" anchor="t" lIns="0" tIns="0" rIns="0" bIns="0" wrap="square"/>
+          <a:lstStyle/>
+          <a:p>
+            <a:pPr algn="l">
+              <a:buNone/>
+            </a:pPr>
+            <a:r>
+              <a:rPr sz="1000" b="0" i="0">
+                <a:solidFill>
+                  <a:srgbClr val="1F2937"/>
+                </a:solidFill>
+                <a:latin typeface="Arial"/>
+              </a:rPr>
+              <a:t>Metadata, ELA, shadows, reverse image, C2PA, video cuts, CIB - converge, never one test.</a:t>
             </a:r>
           </a:p>
         </p:txBody>

</xml_diff>

<commit_message>
Day 2 deck: align the afternoon red thread with the four actual TPs
Afternoon now maps to the labs in Day_2/: Email Harvester, API Scraping, Geosint,
Data Breach (Media Forensics kept as theory + bonus lab, not in the red thread).
Schedule, overview, per-TP markers and the deliverable updated to the Admiralty-rated
'sourced note' thread, with a Day 1 collection recall. Morning theory unchanged.
</commit_message>
<xml_diff>
--- a/Day_2/Day_2_Source_Reliability_And_Media_Forensics.pptx
+++ b/Day_2/Day_2_Source_Reliability_And_Media_Forensics.pptx
@@ -34,6 +34,7 @@
     <p:sldId id="282" r:id="rId33"/>
     <p:sldId id="283" r:id="rId34"/>
     <p:sldId id="284" r:id="rId35"/>
+    <p:sldId id="289" r:id="rId40"/>
     <p:sldId id="285" r:id="rId36"/>
     <p:sldId id="288" r:id="rId39"/>
     <p:sldId id="286" r:id="rId37"/>
@@ -10149,6 +10150,30 @@
               <a:t>Verify a media's provenance with cryptographic credentials (C2PA).</a:t>
             </a:r>
           </a:p>
+          <a:p>
+            <a:pPr algn="l" marL="228600" indent="-228600">
+              <a:lnSpc>
+                <a:spcPct val="105000"/>
+              </a:lnSpc>
+              <a:spcAft>
+                <a:spcPts val="600"/>
+              </a:spcAft>
+              <a:buClr>
+                <a:srgbClr val="1E40AF"/>
+              </a:buClr>
+              <a:buFont typeface="Arial"/>
+              <a:buChar char="•"/>
+            </a:pPr>
+            <a:r>
+              <a:rPr sz="1100" b="0" i="0">
+                <a:solidFill>
+                  <a:srgbClr val="1F2937"/>
+                </a:solidFill>
+                <a:latin typeface="Arial"/>
+              </a:rPr>
+              <a:t>Collect at scale and report clean: recursive scraping, API replay, dump analysis - every finding Admiralty-rated.</a:t>
+            </a:r>
+          </a:p>
         </p:txBody>
       </p:sp>
     </p:spTree>
@@ -16261,7 +16286,7 @@
                 </a:solidFill>
                 <a:latin typeface="Arial"/>
               </a:rPr>
-              <a:t>From toolbox to verdict</a:t>
+              <a:t>Collection, verification, reporting</a:t>
             </a:r>
           </a:p>
         </p:txBody>
@@ -16660,7 +16685,7 @@
                 </a:solidFill>
                 <a:latin typeface="Arial"/>
               </a:rPr>
-              <a:t>Four hands-on TPs, in order. Each applies this morning's theory; the cheat sheets are your toolbox.</a:t>
+              <a:t>Four hands-on TPs. Collection techniques (Day 1 recall) applied with Day 2 rigour: sourcing, Admiralty, provenance.</a:t>
             </a:r>
           </a:p>
         </p:txBody>
@@ -16794,7 +16819,7 @@
                           </a:solidFill>
                           <a:latin typeface="Arial"/>
                         </a:rPr>
-                        <a:t>Scripting toolbox - Email Harvester (curl+regex) + API Scraping (Burp+Python)</a:t>
+                        <a:t>Email Harvester - recursive scraping (bash, curl, regex)</a:t>
                       </a:r>
                     </a:p>
                   </a:txBody>
@@ -16817,7 +16842,7 @@
                           </a:solidFill>
                           <a:latin typeface="Arial"/>
                         </a:rPr>
-                        <a:t>90 min</a:t>
+                        <a:t>60 min</a:t>
                       </a:r>
                     </a:p>
                   </a:txBody>
@@ -16865,7 +16890,7 @@
                           </a:solidFill>
                           <a:latin typeface="Arial"/>
                         </a:rPr>
-                        <a:t>Geosint - Operation Glass Eye (geolocation &amp; chronolocation)</a:t>
+                        <a:t>API Scraping - Burp interception + Python replay</a:t>
                       </a:r>
                     </a:p>
                   </a:txBody>
@@ -16936,7 +16961,7 @@
                           </a:solidFill>
                           <a:latin typeface="Arial"/>
                         </a:rPr>
-                        <a:t>Media Forensics - Operation Riverbank (authenticate &amp; dismantle)</a:t>
+                        <a:t>Geosint - Operation Glass Eye (geolocation &amp; chronolocation)</a:t>
                       </a:r>
                     </a:p>
                   </a:txBody>
@@ -16959,7 +16984,7 @@
                           </a:solidFill>
                           <a:latin typeface="Arial"/>
                         </a:rPr>
-                        <a:t>75 min</a:t>
+                        <a:t>60 min</a:t>
                       </a:r>
                     </a:p>
                   </a:txBody>
@@ -16984,7 +17009,7 @@
                           </a:solidFill>
                           <a:latin typeface="Arial"/>
                         </a:rPr>
-                        <a:t>Deliverable</a:t>
+                        <a:t>4</a:t>
                       </a:r>
                     </a:p>
                   </a:txBody>
@@ -17007,7 +17032,7 @@
                           </a:solidFill>
                           <a:latin typeface="Arial"/>
                         </a:rPr>
-                        <a:t>One verification note per case (verdict + provenance + rating)</a:t>
+                        <a:t>Data Breach - leaked SQL dump, Python/pandas analysis</a:t>
                       </a:r>
                     </a:p>
                   </a:txBody>
@@ -17030,7 +17055,7 @@
                           </a:solidFill>
                           <a:latin typeface="Arial"/>
                         </a:rPr>
-                        <a:t>-</a:t>
+                        <a:t>75 min</a:t>
                       </a:r>
                     </a:p>
                   </a:txBody>
@@ -17055,7 +17080,7 @@
                           </a:solidFill>
                           <a:latin typeface="Arial"/>
                         </a:rPr>
-                        <a:t>Toolbox</a:t>
+                        <a:t>Deliverable</a:t>
                       </a:r>
                     </a:p>
                   </a:txBody>
@@ -17078,7 +17103,7 @@
                           </a:solidFill>
                           <a:latin typeface="Arial"/>
                         </a:rPr>
-                        <a:t>Cheat sheets: Linux basics, Bash scripting, Kali/OSINT tools</a:t>
+                        <a:t>One sourced note per TP: findings + Admiralty rating + provenance</a:t>
                       </a:r>
                     </a:p>
                   </a:txBody>
@@ -17259,7 +17284,7 @@
                 </a:solidFill>
                 <a:latin typeface="Arial"/>
               </a:rPr>
-              <a:t>Build your toolbox (scripting)</a:t>
+              <a:t>Email Harvester - recursive scraping</a:t>
             </a:r>
           </a:p>
         </p:txBody>
@@ -17411,7 +17436,7 @@
                 </a:solidFill>
                 <a:latin typeface="Arial"/>
               </a:rPr>
-              <a:t>Harvest data with curl + regex, then scrape an API you captured with Burp + Python.</a:t>
+              <a:t>Fetch a page, extract e-mails with a regex, follow the links: build your own crawler.</a:t>
             </a:r>
           </a:p>
         </p:txBody>
@@ -17513,7 +17538,7 @@
                 </a:solidFill>
                 <a:latin typeface="Consolas"/>
               </a:rPr>
-              <a:t># Recursive e-mail harvest (bash + curl + regex)</a:t>
+              <a:t># Recursive e-mail harvester (bash + curl + regex)</a:t>
             </a:r>
           </a:p>
           <a:p>
@@ -17530,7 +17555,7 @@
                 </a:solidFill>
                 <a:latin typeface="Consolas"/>
               </a:rPr>
-              <a:t>curl -sL "$URL" | grep -oE '[A-Za-z0-9._%+-]+@[A-Za-z0-9.-]+\.[A-Za-z]{2,}'</a:t>
+              <a:t>EMAIL='[A-Za-z0-9._%+-]+@[A-Za-z0-9.-]+\.[A-Za-z]{2,}'</a:t>
             </a:r>
           </a:p>
           <a:p>
@@ -17547,7 +17572,7 @@
                 </a:solidFill>
                 <a:latin typeface="Consolas"/>
               </a:rPr>
-              <a:t>./harvest.sh http://target/ 2        # crawl depth 2  -&gt; emails.csv</a:t>
+              <a:t>curl -sL "$URL" | grep -oE "$EMAIL" | sort -u        # e-mails on one page</a:t>
             </a:r>
           </a:p>
           <a:p>
@@ -17564,7 +17589,7 @@
                 </a:solidFill>
                 <a:latin typeface="Consolas"/>
               </a:rPr>
-              <a:t/>
+              <a:t>./harvest.sh http://target/ 2                          # crawl depth 2 -&gt; emails.csv</a:t>
             </a:r>
           </a:p>
           <a:p>
@@ -17577,11 +17602,11 @@
             <a:r>
               <a:rPr sz="1050" b="0" i="0">
                 <a:solidFill>
-                  <a:srgbClr val="6B7280"/>
+                  <a:srgbClr val="1F2937"/>
                 </a:solidFill>
                 <a:latin typeface="Consolas"/>
               </a:rPr>
-              <a:t># Replay a captured API request (python + requests)</a:t>
+              <a:t/>
             </a:r>
           </a:p>
           <a:p>
@@ -17594,11 +17619,11 @@
             <a:r>
               <a:rPr sz="1050" b="0" i="0">
                 <a:solidFill>
-                  <a:srgbClr val="1F2937"/>
+                  <a:srgbClr val="6B7280"/>
                 </a:solidFill>
                 <a:latin typeface="Consolas"/>
               </a:rPr>
-              <a:t>r = session.get(url, headers={"Authorization": f"Bearer {token}"})</a:t>
+              <a:t># curl has NO recursion flag: we build the crawl ourselves</a:t>
             </a:r>
           </a:p>
           <a:p>
@@ -17611,11 +17636,11 @@
             <a:r>
               <a:rPr sz="1050" b="0" i="0">
                 <a:solidFill>
-                  <a:srgbClr val="1F2937"/>
+                  <a:srgbClr val="6B7280"/>
                 </a:solidFill>
                 <a:latin typeface="Consolas"/>
               </a:rPr>
-              <a:t>df = pd.json_normalize(r.json()["hits"]); df.to_csv("products.csv")</a:t>
+              <a:t># (queue + visited set + same-domain filter + relative-link resolver)</a:t>
             </a:r>
           </a:p>
         </p:txBody>
@@ -17813,7 +17838,7 @@
                 </a:solidFill>
                 <a:latin typeface="Arial"/>
               </a:rPr>
-              <a:t>Reference: Linux basics, Bash scripting, Kali/OSINT tools. Authorised targets only.</a:t>
+              <a:t>Reference: Linux basics + Bash scripting. Authorised targets only; respect robots.txt.</a:t>
             </a:r>
           </a:p>
         </p:txBody>
@@ -18389,7 +18414,7 @@
                           </a:solidFill>
                           <a:latin typeface="Arial"/>
                         </a:rPr>
-                        <a:t>Media forensics: signal &amp; provenance</a:t>
+                        <a:t>Scraping &amp; collection: Email Harvester, API Scraping</a:t>
                       </a:r>
                     </a:p>
                   </a:txBody>
@@ -18460,7 +18485,7 @@
                           </a:solidFill>
                           <a:latin typeface="Arial"/>
                         </a:rPr>
-                        <a:t>Deepfakes &amp; verification note</a:t>
+                        <a:t>Geosint + Data Breach, with Admiralty-rated notes</a:t>
                       </a:r>
                     </a:p>
                   </a:txBody>
@@ -18588,7 +18613,7 @@
                 </a:solidFill>
                 <a:latin typeface="Arial"/>
               </a:rPr>
-              <a:t>LAB - TP 2</a:t>
+              <a:t>LAB - TP 3</a:t>
             </a:r>
           </a:p>
         </p:txBody>
@@ -19307,7 +19332,7 @@
                 </a:solidFill>
                 <a:latin typeface="Arial"/>
               </a:rPr>
-              <a:t>LAB — AFTERNOON</a:t>
+              <a:t>LAB - TP 4</a:t>
             </a:r>
           </a:p>
         </p:txBody>
@@ -19360,7 +19385,7 @@
                 </a:solidFill>
                 <a:latin typeface="Arial"/>
               </a:rPr>
-              <a:t>Deliverable: verification note</a:t>
+              <a:t>Data Breach - dump analysis</a:t>
             </a:r>
           </a:p>
         </p:txBody>
@@ -19512,7 +19537,7 @@
                 </a:solidFill>
                 <a:latin typeface="Arial"/>
               </a:rPr>
-              <a:t>A structured, sourced, auditable note.</a:t>
+              <a:t>Load a leaked SQL dump locally, map its schema, quantify the exposure with Python.</a:t>
             </a:r>
           </a:p>
         </p:txBody>
@@ -19525,8 +19550,54 @@
         </p:nvSpPr>
         <p:spPr>
           <a:xfrm>
-            <a:off x="457200" y="1837360"/>
-            <a:ext cx="8229600" cy="2662640"/>
+            <a:off x="457200" y="1828800"/>
+            <a:ext cx="8229600" cy="2360000"/>
+          </a:xfrm>
+          <a:prstGeom prst="rect">
+            <a:avLst/>
+          </a:prstGeom>
+          <a:solidFill>
+            <a:srgbClr val="F9FAFB"/>
+          </a:solidFill>
+          <a:ln w="6350">
+            <a:solidFill>
+              <a:srgbClr val="E5E7EB"/>
+            </a:solidFill>
+          </a:ln>
+          <a:effectLst/>
+        </p:spPr>
+        <p:style>
+          <a:lnRef idx="1">
+            <a:schemeClr val="accent1"/>
+          </a:lnRef>
+          <a:fillRef idx="3">
+            <a:schemeClr val="accent1"/>
+          </a:fillRef>
+          <a:effectRef idx="2">
+            <a:schemeClr val="accent1"/>
+          </a:effectRef>
+          <a:fontRef idx="minor">
+            <a:schemeClr val="lt1"/>
+          </a:fontRef>
+        </p:style>
+        <p:txBody>
+          <a:bodyPr rtlCol="0" anchor="ctr"/>
+          <a:lstStyle/>
+          <a:p>
+            <a:pPr algn="ctr"/>
+          </a:p>
+        </p:txBody>
+      </p:sp>
+      <p:sp>
+        <p:nvSpPr>
+          <p:cNvPr id="9" name="Rectangle 8"/>
+          <p:cNvSpPr/>
+          <p:nvPr/>
+        </p:nvSpPr>
+        <p:spPr>
+          <a:xfrm>
+            <a:off x="594360" y="1920240"/>
+            <a:ext cx="7955280" cy="2177120"/>
           </a:xfrm>
           <a:prstGeom prst="rect">
             <a:avLst/>
@@ -19555,123 +19626,320 @@
           <a:bodyPr rtlCol="0" anchor="t" lIns="0" tIns="0" rIns="0" bIns="0" wrap="square"/>
           <a:lstStyle/>
           <a:p>
-            <a:pPr algn="l" marL="228600" indent="-228600">
+            <a:pPr algn="l">
               <a:lnSpc>
-                <a:spcPct val="105000"/>
+                <a:spcPct val="102000"/>
               </a:lnSpc>
-              <a:spcAft>
-                <a:spcPts val="600"/>
-              </a:spcAft>
-              <a:buClr>
-                <a:srgbClr val="1E40AF"/>
-              </a:buClr>
-              <a:buFont typeface="Arial"/>
-              <a:buChar char="•"/>
-            </a:pPr>
-            <a:r>
-              <a:rPr sz="1100" b="0" i="0">
+              <a:buNone/>
+            </a:pPr>
+            <a:r>
+              <a:rPr sz="1050" b="0" i="0">
+                <a:solidFill>
+                  <a:srgbClr val="6B7280"/>
+                </a:solidFill>
+                <a:latin typeface="Consolas"/>
+              </a:rPr>
+              <a:t># Leaked SQL dump -&gt; local DB -&gt; READ-ONLY analysis (SQLAlchemy + pandas)</a:t>
+            </a:r>
+          </a:p>
+          <a:p>
+            <a:pPr algn="l">
+              <a:lnSpc>
+                <a:spcPct val="102000"/>
+              </a:lnSpc>
+              <a:buNone/>
+            </a:pPr>
+            <a:r>
+              <a:rPr sz="1050" b="0" i="0">
                 <a:solidFill>
                   <a:srgbClr val="1F2937"/>
                 </a:solidFill>
-                <a:latin typeface="Arial"/>
-              </a:rPr>
-              <a:t>Graded verdict: authentic / misleading / manipulated / synthetic / unverifiable.</a:t>
-            </a:r>
-          </a:p>
-          <a:p>
-            <a:pPr algn="l" marL="228600" indent="-228600">
+                <a:latin typeface="Consolas"/>
+              </a:rPr>
+              <a:t>from sqlalchemy import create_engine; import pandas as pd</a:t>
+            </a:r>
+          </a:p>
+          <a:p>
+            <a:pPr algn="l">
               <a:lnSpc>
-                <a:spcPct val="105000"/>
+                <a:spcPct val="102000"/>
               </a:lnSpc>
-              <a:spcAft>
-                <a:spcPts val="600"/>
-              </a:spcAft>
-              <a:buClr>
-                <a:srgbClr val="1E40AF"/>
-              </a:buClr>
-              <a:buFont typeface="Arial"/>
-              <a:buChar char="•"/>
-            </a:pPr>
-            <a:r>
-              <a:rPr sz="1100" b="0" i="0">
+              <a:buNone/>
+            </a:pPr>
+            <a:r>
+              <a:rPr sz="1050" b="0" i="0">
                 <a:solidFill>
                   <a:srgbClr val="1F2937"/>
                 </a:solidFill>
-                <a:latin typeface="Arial"/>
-              </a:rPr>
-              <a:t>Provenance: first occurrence, source, archiving (URL + hash + UTC).</a:t>
-            </a:r>
-          </a:p>
-          <a:p>
-            <a:pPr algn="l" marL="228600" indent="-228600">
+                <a:latin typeface="Consolas"/>
+              </a:rPr>
+              <a:t>eng = create_engine("mysql+pymysql://user:pw@127.0.0.1:3306/leak")</a:t>
+            </a:r>
+          </a:p>
+          <a:p>
+            <a:pPr algn="l">
               <a:lnSpc>
-                <a:spcPct val="105000"/>
+                <a:spcPct val="102000"/>
               </a:lnSpc>
-              <a:spcAft>
-                <a:spcPts val="600"/>
-              </a:spcAft>
-              <a:buClr>
-                <a:srgbClr val="1E40AF"/>
-              </a:buClr>
-              <a:buFont typeface="Arial"/>
-              <a:buChar char="•"/>
-            </a:pPr>
-            <a:r>
-              <a:rPr sz="1100" b="0" i="0">
+              <a:buNone/>
+            </a:pPr>
+            <a:r>
+              <a:rPr sz="1050" b="0" i="0">
                 <a:solidFill>
                   <a:srgbClr val="1F2937"/>
                 </a:solidFill>
-                <a:latin typeface="Arial"/>
-              </a:rPr>
-              <a:t>Metadata, signal, geo/chrono, context — each documented.</a:t>
-            </a:r>
-          </a:p>
-          <a:p>
-            <a:pPr algn="l" marL="228600" indent="-228600">
+                <a:latin typeface="Consolas"/>
+              </a:rPr>
+              <a:t>pd.read_sql("SELECT COUNT(*) FROM information_schema.tables "</a:t>
+            </a:r>
+          </a:p>
+          <a:p>
+            <a:pPr algn="l">
               <a:lnSpc>
-                <a:spcPct val="105000"/>
+                <a:spcPct val="102000"/>
               </a:lnSpc>
-              <a:spcAft>
-                <a:spcPts val="600"/>
-              </a:spcAft>
-              <a:buClr>
-                <a:srgbClr val="1E40AF"/>
-              </a:buClr>
-              <a:buFont typeface="Arial"/>
-              <a:buChar char="•"/>
-            </a:pPr>
-            <a:r>
-              <a:rPr sz="1100" b="0" i="0">
+              <a:buNone/>
+            </a:pPr>
+            <a:r>
+              <a:rPr sz="1050" b="0" i="0">
                 <a:solidFill>
                   <a:srgbClr val="1F2937"/>
                 </a:solidFill>
-                <a:latin typeface="Arial"/>
-              </a:rPr>
-              <a:t>If relevant: CIB indicators and amplification network.</a:t>
-            </a:r>
-          </a:p>
-          <a:p>
-            <a:pPr algn="l" marL="228600" indent="-228600">
+                <a:latin typeface="Consolas"/>
+              </a:rPr>
+              <a:t>            "WHERE table_schema=DATABASE()", eng)      # map the schema</a:t>
+            </a:r>
+          </a:p>
+          <a:p>
+            <a:pPr algn="l">
               <a:lnSpc>
-                <a:spcPct val="105000"/>
+                <a:spcPct val="102000"/>
               </a:lnSpc>
-              <a:spcAft>
-                <a:spcPts val="600"/>
-              </a:spcAft>
-              <a:buClr>
-                <a:srgbClr val="1E40AF"/>
-              </a:buClr>
-              <a:buFont typeface="Arial"/>
-              <a:buChar char="•"/>
-            </a:pPr>
-            <a:r>
-              <a:rPr sz="1100" b="0" i="0">
+              <a:buNone/>
+            </a:pPr>
+            <a:r>
+              <a:rPr sz="1050" b="0" i="0">
                 <a:solidFill>
                   <a:srgbClr val="1F2937"/>
                 </a:solidFill>
-                <a:latin typeface="Arial"/>
-              </a:rPr>
-              <a:t>Conclusion based on the WEIGHT OF EVIDENCE, not one clue.</a:t>
+                <a:latin typeface="Consolas"/>
+              </a:rPr>
+              <a:t>df = pd.read_sql("SELECT email, created FROM users", eng)  # extract &amp; aggregate</a:t>
+            </a:r>
+          </a:p>
+          <a:p>
+            <a:pPr algn="l">
+              <a:lnSpc>
+                <a:spcPct val="102000"/>
+              </a:lnSpc>
+              <a:buNone/>
+            </a:pPr>
+            <a:r>
+              <a:rPr sz="1050" b="0" i="0">
+                <a:solidFill>
+                  <a:srgbClr val="1F2937"/>
+                </a:solidFill>
+                <a:latin typeface="Consolas"/>
+              </a:rPr>
+              <a:t>df.to_csv("exposure.csv", index=False)                 # export (anonymised)</a:t>
+            </a:r>
+          </a:p>
+        </p:txBody>
+      </p:sp>
+      <p:sp>
+        <p:nvSpPr>
+          <p:cNvPr id="10" name="Rectangle 9"/>
+          <p:cNvSpPr/>
+          <p:nvPr/>
+        </p:nvSpPr>
+        <p:spPr>
+          <a:xfrm>
+            <a:off x="457200" y="4434840"/>
+            <a:ext cx="8229600" cy="411480"/>
+          </a:xfrm>
+          <a:prstGeom prst="rect">
+            <a:avLst/>
+          </a:prstGeom>
+          <a:solidFill>
+            <a:srgbClr val="F3F4F6"/>
+          </a:solidFill>
+          <a:ln w="12700">
+            <a:solidFill>
+              <a:srgbClr val="F3F4F6"/>
+            </a:solidFill>
+          </a:ln>
+          <a:effectLst/>
+        </p:spPr>
+        <p:style>
+          <a:lnRef idx="1">
+            <a:schemeClr val="accent1"/>
+          </a:lnRef>
+          <a:fillRef idx="3">
+            <a:schemeClr val="accent1"/>
+          </a:fillRef>
+          <a:effectRef idx="2">
+            <a:schemeClr val="accent1"/>
+          </a:effectRef>
+          <a:fontRef idx="minor">
+            <a:schemeClr val="lt1"/>
+          </a:fontRef>
+        </p:style>
+        <p:txBody>
+          <a:bodyPr rtlCol="0" anchor="ctr"/>
+          <a:lstStyle/>
+          <a:p>
+            <a:pPr algn="ctr"/>
+          </a:p>
+        </p:txBody>
+      </p:sp>
+      <p:sp>
+        <p:nvSpPr>
+          <p:cNvPr id="11" name="Rectangle 10"/>
+          <p:cNvSpPr/>
+          <p:nvPr/>
+        </p:nvSpPr>
+        <p:spPr>
+          <a:xfrm>
+            <a:off x="457200" y="4434840"/>
+            <a:ext cx="73152" cy="411480"/>
+          </a:xfrm>
+          <a:prstGeom prst="rect">
+            <a:avLst/>
+          </a:prstGeom>
+          <a:solidFill>
+            <a:srgbClr val="1E40AF"/>
+          </a:solidFill>
+          <a:ln w="12700">
+            <a:solidFill>
+              <a:srgbClr val="1E40AF"/>
+            </a:solidFill>
+          </a:ln>
+          <a:effectLst/>
+        </p:spPr>
+        <p:style>
+          <a:lnRef idx="1">
+            <a:schemeClr val="accent1"/>
+          </a:lnRef>
+          <a:fillRef idx="3">
+            <a:schemeClr val="accent1"/>
+          </a:fillRef>
+          <a:effectRef idx="2">
+            <a:schemeClr val="accent1"/>
+          </a:effectRef>
+          <a:fontRef idx="minor">
+            <a:schemeClr val="lt1"/>
+          </a:fontRef>
+        </p:style>
+        <p:txBody>
+          <a:bodyPr rtlCol="0" anchor="ctr"/>
+          <a:lstStyle/>
+          <a:p>
+            <a:pPr algn="ctr"/>
+          </a:p>
+        </p:txBody>
+      </p:sp>
+      <p:sp>
+        <p:nvSpPr>
+          <p:cNvPr id="12" name="Rectangle 11"/>
+          <p:cNvSpPr/>
+          <p:nvPr/>
+        </p:nvSpPr>
+        <p:spPr>
+          <a:xfrm>
+            <a:off x="640080" y="4464840"/>
+            <a:ext cx="7955280" cy="200000"/>
+          </a:xfrm>
+          <a:prstGeom prst="rect">
+            <a:avLst/>
+          </a:prstGeom>
+          <a:noFill/>
+          <a:ln>
+            <a:noFill/>
+          </a:ln>
+          <a:effectLst/>
+        </p:spPr>
+        <p:style>
+          <a:lnRef idx="1">
+            <a:schemeClr val="accent1"/>
+          </a:lnRef>
+          <a:fillRef idx="3">
+            <a:schemeClr val="accent1"/>
+          </a:fillRef>
+          <a:effectRef idx="2">
+            <a:schemeClr val="accent1"/>
+          </a:effectRef>
+          <a:fontRef idx="minor">
+            <a:schemeClr val="lt1"/>
+          </a:fontRef>
+        </p:style>
+        <p:txBody>
+          <a:bodyPr rtlCol="0" anchor="ctr" lIns="0" tIns="0" rIns="0" bIns="0" wrap="square"/>
+          <a:lstStyle/>
+          <a:p>
+            <a:pPr algn="l">
+              <a:buNone/>
+            </a:pPr>
+            <a:r>
+              <a:rPr sz="1000" b="1" i="0">
+                <a:solidFill>
+                  <a:srgbClr val="1E40AF"/>
+                </a:solidFill>
+                <a:latin typeface="Arial"/>
+              </a:rPr>
+              <a:t>GDPR</a:t>
+            </a:r>
+          </a:p>
+        </p:txBody>
+      </p:sp>
+      <p:sp>
+        <p:nvSpPr>
+          <p:cNvPr id="13" name="Rectangle 12"/>
+          <p:cNvSpPr/>
+          <p:nvPr/>
+        </p:nvSpPr>
+        <p:spPr>
+          <a:xfrm>
+            <a:off x="640080" y="4644840"/>
+            <a:ext cx="7955280" cy="190000"/>
+          </a:xfrm>
+          <a:prstGeom prst="rect">
+            <a:avLst/>
+          </a:prstGeom>
+          <a:noFill/>
+          <a:ln>
+            <a:noFill/>
+          </a:ln>
+          <a:effectLst/>
+        </p:spPr>
+        <p:style>
+          <a:lnRef idx="1">
+            <a:schemeClr val="accent1"/>
+          </a:lnRef>
+          <a:fillRef idx="3">
+            <a:schemeClr val="accent1"/>
+          </a:fillRef>
+          <a:effectRef idx="2">
+            <a:schemeClr val="accent1"/>
+          </a:effectRef>
+          <a:fontRef idx="minor">
+            <a:schemeClr val="lt1"/>
+          </a:fontRef>
+        </p:style>
+        <p:txBody>
+          <a:bodyPr rtlCol="0" anchor="t" lIns="0" tIns="0" rIns="0" bIns="0" wrap="square"/>
+          <a:lstStyle/>
+          <a:p>
+            <a:pPr algn="l">
+              <a:buNone/>
+            </a:pPr>
+            <a:r>
+              <a:rPr sz="1000" b="0" i="0">
+                <a:solidFill>
+                  <a:srgbClr val="1F2937"/>
+                </a:solidFill>
+                <a:latin typeface="Arial"/>
+              </a:rPr>
+              <a:t>Read-only. Anonymise output, never re-identify. Assess and report the exposure.</a:t>
             </a:r>
           </a:p>
         </p:txBody>
@@ -19766,7 +20034,7 @@
                 </a:solidFill>
                 <a:latin typeface="Arial"/>
               </a:rPr>
-              <a:t>KEY TAKEAWAYS</a:t>
+              <a:t>LAB — AFTERNOON</a:t>
             </a:r>
           </a:p>
         </p:txBody>
@@ -19819,7 +20087,7 @@
                 </a:solidFill>
                 <a:latin typeface="Arial"/>
               </a:rPr>
-              <a:t>Day 2 key takeaways</a:t>
+              <a:t>Deliverable: sourced note (Admiralty)</a:t>
             </a:r>
           </a:p>
         </p:txBody>
@@ -19971,7 +20239,7 @@
                 </a:solidFill>
                 <a:latin typeface="Arial"/>
               </a:rPr>
-              <a:t>End-of-day quiz to follow.</a:t>
+              <a:t>A structured, sourced, auditable note - one per TP.</a:t>
             </a:r>
           </a:p>
         </p:txBody>
@@ -20034,7 +20302,7 @@
                 </a:solidFill>
                 <a:latin typeface="Arial"/>
               </a:rPr>
-              <a:t>A visual has no evidentiary value by default: it must be authenticated.</a:t>
+              <a:t>The finding, with its Admiralty rating (source A-F x information 1-6).</a:t>
             </a:r>
           </a:p>
           <a:p>
@@ -20058,7 +20326,7 @@
                 </a:solidFill>
                 <a:latin typeface="Arial"/>
               </a:rPr>
-              <a:t>Chain: provenance, source, date, place, motivation.</a:t>
+              <a:t>Provenance: source URL, UTC timestamp, SHA-256 of every captured artefact (Day 1 discipline).</a:t>
             </a:r>
           </a:p>
           <a:p>
@@ -20082,7 +20350,7 @@
                 </a:solidFill>
                 <a:latin typeface="Arial"/>
               </a:rPr>
-              <a:t>Metadata and ELA point the way; reason by convergence.</a:t>
+              <a:t>Reproducible: an auditor should reach the same conclusion from your note.</a:t>
             </a:r>
           </a:p>
           <a:p>
@@ -20106,253 +20374,7 @@
                 </a:solidFill>
                 <a:latin typeface="Arial"/>
               </a:rPr>
-              <a:t>Deepfakes: prioritise provenance (C2PA) and cross-checking.</a:t>
-            </a:r>
-          </a:p>
-          <a:p>
-            <a:pPr algn="l" marL="228600" indent="-228600">
-              <a:lnSpc>
-                <a:spcPct val="105000"/>
-              </a:lnSpc>
-              <a:spcAft>
-                <a:spcPts val="600"/>
-              </a:spcAft>
-              <a:buClr>
-                <a:srgbClr val="1E40AF"/>
-              </a:buClr>
-              <a:buFont typeface="Arial"/>
-              <a:buChar char="•"/>
-            </a:pPr>
-            <a:r>
-              <a:rPr sz="1100" b="0" i="0">
-                <a:solidFill>
-                  <a:srgbClr val="1F2937"/>
-                </a:solidFill>
-                <a:latin typeface="Arial"/>
-              </a:rPr>
-              <a:t>The dominant lie is recontextualisation → reverse image.</a:t>
-            </a:r>
-          </a:p>
-          <a:p>
-            <a:pPr algn="l" marL="228600" indent="-228600">
-              <a:lnSpc>
-                <a:spcPct val="105000"/>
-              </a:lnSpc>
-              <a:spcAft>
-                <a:spcPts val="600"/>
-              </a:spcAft>
-              <a:buClr>
-                <a:srgbClr val="1E40AF"/>
-              </a:buClr>
-              <a:buFont typeface="Arial"/>
-              <a:buChar char="•"/>
-            </a:pPr>
-            <a:r>
-              <a:rPr sz="1100" b="0" i="0">
-                <a:solidFill>
-                  <a:srgbClr val="1F2937"/>
-                </a:solidFill>
-                <a:latin typeface="Arial"/>
-              </a:rPr>
-              <a:t>Disinformation: isolate, source, detect CIB through network analysis.</a:t>
-            </a:r>
-          </a:p>
-        </p:txBody>
-      </p:sp>
-      <p:sp>
-        <p:nvSpPr>
-          <p:cNvPr id="9" name="Rectangle 8"/>
-          <p:cNvSpPr/>
-          <p:nvPr/>
-        </p:nvSpPr>
-        <p:spPr>
-          <a:xfrm>
-            <a:off x="457200" y="4434840"/>
-            <a:ext cx="8229600" cy="411480"/>
-          </a:xfrm>
-          <a:prstGeom prst="rect">
-            <a:avLst/>
-          </a:prstGeom>
-          <a:solidFill>
-            <a:srgbClr val="F3F4F6"/>
-          </a:solidFill>
-          <a:ln w="12700">
-            <a:solidFill>
-              <a:srgbClr val="F3F4F6"/>
-            </a:solidFill>
-          </a:ln>
-          <a:effectLst/>
-        </p:spPr>
-        <p:style>
-          <a:lnRef idx="1">
-            <a:schemeClr val="accent1"/>
-          </a:lnRef>
-          <a:fillRef idx="3">
-            <a:schemeClr val="accent1"/>
-          </a:fillRef>
-          <a:effectRef idx="2">
-            <a:schemeClr val="accent1"/>
-          </a:effectRef>
-          <a:fontRef idx="minor">
-            <a:schemeClr val="lt1"/>
-          </a:fontRef>
-        </p:style>
-        <p:txBody>
-          <a:bodyPr rtlCol="0" anchor="ctr"/>
-          <a:lstStyle/>
-          <a:p>
-            <a:pPr algn="ctr"/>
-          </a:p>
-        </p:txBody>
-      </p:sp>
-      <p:sp>
-        <p:nvSpPr>
-          <p:cNvPr id="10" name="Rectangle 9"/>
-          <p:cNvSpPr/>
-          <p:nvPr/>
-        </p:nvSpPr>
-        <p:spPr>
-          <a:xfrm>
-            <a:off x="457200" y="4434840"/>
-            <a:ext cx="73152" cy="411480"/>
-          </a:xfrm>
-          <a:prstGeom prst="rect">
-            <a:avLst/>
-          </a:prstGeom>
-          <a:solidFill>
-            <a:srgbClr val="15803D"/>
-          </a:solidFill>
-          <a:ln w="12700">
-            <a:solidFill>
-              <a:srgbClr val="15803D"/>
-            </a:solidFill>
-          </a:ln>
-          <a:effectLst/>
-        </p:spPr>
-        <p:style>
-          <a:lnRef idx="1">
-            <a:schemeClr val="accent1"/>
-          </a:lnRef>
-          <a:fillRef idx="3">
-            <a:schemeClr val="accent1"/>
-          </a:fillRef>
-          <a:effectRef idx="2">
-            <a:schemeClr val="accent1"/>
-          </a:effectRef>
-          <a:fontRef idx="minor">
-            <a:schemeClr val="lt1"/>
-          </a:fontRef>
-        </p:style>
-        <p:txBody>
-          <a:bodyPr rtlCol="0" anchor="ctr"/>
-          <a:lstStyle/>
-          <a:p>
-            <a:pPr algn="ctr"/>
-          </a:p>
-        </p:txBody>
-      </p:sp>
-      <p:sp>
-        <p:nvSpPr>
-          <p:cNvPr id="11" name="Rectangle 10"/>
-          <p:cNvSpPr/>
-          <p:nvPr/>
-        </p:nvSpPr>
-        <p:spPr>
-          <a:xfrm>
-            <a:off x="640080" y="4464840"/>
-            <a:ext cx="7955280" cy="200000"/>
-          </a:xfrm>
-          <a:prstGeom prst="rect">
-            <a:avLst/>
-          </a:prstGeom>
-          <a:noFill/>
-          <a:ln>
-            <a:noFill/>
-          </a:ln>
-          <a:effectLst/>
-        </p:spPr>
-        <p:style>
-          <a:lnRef idx="1">
-            <a:schemeClr val="accent1"/>
-          </a:lnRef>
-          <a:fillRef idx="3">
-            <a:schemeClr val="accent1"/>
-          </a:fillRef>
-          <a:effectRef idx="2">
-            <a:schemeClr val="accent1"/>
-          </a:effectRef>
-          <a:fontRef idx="minor">
-            <a:schemeClr val="lt1"/>
-          </a:fontRef>
-        </p:style>
-        <p:txBody>
-          <a:bodyPr rtlCol="0" anchor="ctr" lIns="0" tIns="0" rIns="0" bIns="0" wrap="square"/>
-          <a:lstStyle/>
-          <a:p>
-            <a:pPr algn="l">
-              <a:buNone/>
-            </a:pPr>
-            <a:r>
-              <a:rPr sz="1000" b="1" i="0">
-                <a:solidFill>
-                  <a:srgbClr val="15803D"/>
-                </a:solidFill>
-                <a:latin typeface="Arial"/>
-              </a:rPr>
-              <a:t>NEXT</a:t>
-            </a:r>
-          </a:p>
-        </p:txBody>
-      </p:sp>
-      <p:sp>
-        <p:nvSpPr>
-          <p:cNvPr id="12" name="Rectangle 11"/>
-          <p:cNvSpPr/>
-          <p:nvPr/>
-        </p:nvSpPr>
-        <p:spPr>
-          <a:xfrm>
-            <a:off x="640080" y="4644840"/>
-            <a:ext cx="7955280" cy="190000"/>
-          </a:xfrm>
-          <a:prstGeom prst="rect">
-            <a:avLst/>
-          </a:prstGeom>
-          <a:noFill/>
-          <a:ln>
-            <a:noFill/>
-          </a:ln>
-          <a:effectLst/>
-        </p:spPr>
-        <p:style>
-          <a:lnRef idx="1">
-            <a:schemeClr val="accent1"/>
-          </a:lnRef>
-          <a:fillRef idx="3">
-            <a:schemeClr val="accent1"/>
-          </a:fillRef>
-          <a:effectRef idx="2">
-            <a:schemeClr val="accent1"/>
-          </a:effectRef>
-          <a:fontRef idx="minor">
-            <a:schemeClr val="lt1"/>
-          </a:fontRef>
-        </p:style>
-        <p:txBody>
-          <a:bodyPr rtlCol="0" anchor="t" lIns="0" tIns="0" rIns="0" bIns="0" wrap="square"/>
-          <a:lstStyle/>
-          <a:p>
-            <a:pPr algn="l">
-              <a:buNone/>
-            </a:pPr>
-            <a:r>
-              <a:rPr sz="1000" b="0" i="0">
-                <a:solidFill>
-                  <a:srgbClr val="1F2937"/>
-                </a:solidFill>
-                <a:latin typeface="Arial"/>
-              </a:rPr>
-              <a:t>Day 3 — Dark web, crypto tracing &amp; endpoint forensics (memory analysis).</a:t>
+              <a:t>A clear, graded conclusion - confirmed / probable / possible / unverifiable.</a:t>
             </a:r>
           </a:p>
         </p:txBody>
@@ -20447,7 +20469,7 @@
                 </a:solidFill>
                 <a:latin typeface="Arial"/>
               </a:rPr>
-              <a:t>LAB - TP 3</a:t>
+              <a:t>KEY TAKEAWAYS</a:t>
             </a:r>
           </a:p>
         </p:txBody>
@@ -20500,7 +20522,7 @@
                 </a:solidFill>
                 <a:latin typeface="Arial"/>
               </a:rPr>
-              <a:t>Media Forensics - Operation Riverbank</a:t>
+              <a:t>Day 2 key takeaways</a:t>
             </a:r>
           </a:p>
         </p:txBody>
@@ -20652,7 +20674,688 @@
                 </a:solidFill>
                 <a:latin typeface="Arial"/>
               </a:rPr>
-              <a:t>Authenticate &amp; dismantle a disinformation case: metadata, signal, provenance, video, coordination.</a:t>
+              <a:t>End-of-day quiz to follow.</a:t>
+            </a:r>
+          </a:p>
+        </p:txBody>
+      </p:sp>
+      <p:sp>
+        <p:nvSpPr>
+          <p:cNvPr id="8" name="Rectangle 7"/>
+          <p:cNvSpPr/>
+          <p:nvPr/>
+        </p:nvSpPr>
+        <p:spPr>
+          <a:xfrm>
+            <a:off x="457200" y="1837360"/>
+            <a:ext cx="8229600" cy="2662640"/>
+          </a:xfrm>
+          <a:prstGeom prst="rect">
+            <a:avLst/>
+          </a:prstGeom>
+          <a:noFill/>
+          <a:ln>
+            <a:noFill/>
+          </a:ln>
+          <a:effectLst/>
+        </p:spPr>
+        <p:style>
+          <a:lnRef idx="1">
+            <a:schemeClr val="accent1"/>
+          </a:lnRef>
+          <a:fillRef idx="3">
+            <a:schemeClr val="accent1"/>
+          </a:fillRef>
+          <a:effectRef idx="2">
+            <a:schemeClr val="accent1"/>
+          </a:effectRef>
+          <a:fontRef idx="minor">
+            <a:schemeClr val="lt1"/>
+          </a:fontRef>
+        </p:style>
+        <p:txBody>
+          <a:bodyPr rtlCol="0" anchor="t" lIns="0" tIns="0" rIns="0" bIns="0" wrap="square"/>
+          <a:lstStyle/>
+          <a:p>
+            <a:pPr algn="l" marL="228600" indent="-228600">
+              <a:lnSpc>
+                <a:spcPct val="105000"/>
+              </a:lnSpc>
+              <a:spcAft>
+                <a:spcPts val="600"/>
+              </a:spcAft>
+              <a:buClr>
+                <a:srgbClr val="1E40AF"/>
+              </a:buClr>
+              <a:buFont typeface="Arial"/>
+              <a:buChar char="•"/>
+            </a:pPr>
+            <a:r>
+              <a:rPr sz="1100" b="0" i="0">
+                <a:solidFill>
+                  <a:srgbClr val="1F2937"/>
+                </a:solidFill>
+                <a:latin typeface="Arial"/>
+              </a:rPr>
+              <a:t>A visual has no evidentiary value by default: it must be authenticated.</a:t>
+            </a:r>
+          </a:p>
+          <a:p>
+            <a:pPr algn="l" marL="228600" indent="-228600">
+              <a:lnSpc>
+                <a:spcPct val="105000"/>
+              </a:lnSpc>
+              <a:spcAft>
+                <a:spcPts val="600"/>
+              </a:spcAft>
+              <a:buClr>
+                <a:srgbClr val="1E40AF"/>
+              </a:buClr>
+              <a:buFont typeface="Arial"/>
+              <a:buChar char="•"/>
+            </a:pPr>
+            <a:r>
+              <a:rPr sz="1100" b="0" i="0">
+                <a:solidFill>
+                  <a:srgbClr val="1F2937"/>
+                </a:solidFill>
+                <a:latin typeface="Arial"/>
+              </a:rPr>
+              <a:t>Chain: provenance, source, date, place, motivation.</a:t>
+            </a:r>
+          </a:p>
+          <a:p>
+            <a:pPr algn="l" marL="228600" indent="-228600">
+              <a:lnSpc>
+                <a:spcPct val="105000"/>
+              </a:lnSpc>
+              <a:spcAft>
+                <a:spcPts val="600"/>
+              </a:spcAft>
+              <a:buClr>
+                <a:srgbClr val="1E40AF"/>
+              </a:buClr>
+              <a:buFont typeface="Arial"/>
+              <a:buChar char="•"/>
+            </a:pPr>
+            <a:r>
+              <a:rPr sz="1100" b="0" i="0">
+                <a:solidFill>
+                  <a:srgbClr val="1F2937"/>
+                </a:solidFill>
+                <a:latin typeface="Arial"/>
+              </a:rPr>
+              <a:t>Metadata and ELA point the way; reason by convergence.</a:t>
+            </a:r>
+          </a:p>
+          <a:p>
+            <a:pPr algn="l" marL="228600" indent="-228600">
+              <a:lnSpc>
+                <a:spcPct val="105000"/>
+              </a:lnSpc>
+              <a:spcAft>
+                <a:spcPts val="600"/>
+              </a:spcAft>
+              <a:buClr>
+                <a:srgbClr val="1E40AF"/>
+              </a:buClr>
+              <a:buFont typeface="Arial"/>
+              <a:buChar char="•"/>
+            </a:pPr>
+            <a:r>
+              <a:rPr sz="1100" b="0" i="0">
+                <a:solidFill>
+                  <a:srgbClr val="1F2937"/>
+                </a:solidFill>
+                <a:latin typeface="Arial"/>
+              </a:rPr>
+              <a:t>Deepfakes: prioritise provenance (C2PA) and cross-checking.</a:t>
+            </a:r>
+          </a:p>
+          <a:p>
+            <a:pPr algn="l" marL="228600" indent="-228600">
+              <a:lnSpc>
+                <a:spcPct val="105000"/>
+              </a:lnSpc>
+              <a:spcAft>
+                <a:spcPts val="600"/>
+              </a:spcAft>
+              <a:buClr>
+                <a:srgbClr val="1E40AF"/>
+              </a:buClr>
+              <a:buFont typeface="Arial"/>
+              <a:buChar char="•"/>
+            </a:pPr>
+            <a:r>
+              <a:rPr sz="1100" b="0" i="0">
+                <a:solidFill>
+                  <a:srgbClr val="1F2937"/>
+                </a:solidFill>
+                <a:latin typeface="Arial"/>
+              </a:rPr>
+              <a:t>The dominant lie is recontextualisation → reverse image.</a:t>
+            </a:r>
+          </a:p>
+          <a:p>
+            <a:pPr algn="l" marL="228600" indent="-228600">
+              <a:lnSpc>
+                <a:spcPct val="105000"/>
+              </a:lnSpc>
+              <a:spcAft>
+                <a:spcPts val="600"/>
+              </a:spcAft>
+              <a:buClr>
+                <a:srgbClr val="1E40AF"/>
+              </a:buClr>
+              <a:buFont typeface="Arial"/>
+              <a:buChar char="•"/>
+            </a:pPr>
+            <a:r>
+              <a:rPr sz="1100" b="0" i="0">
+                <a:solidFill>
+                  <a:srgbClr val="1F2937"/>
+                </a:solidFill>
+                <a:latin typeface="Arial"/>
+              </a:rPr>
+              <a:t>Disinformation: isolate, source, detect CIB through network analysis.</a:t>
+            </a:r>
+          </a:p>
+        </p:txBody>
+      </p:sp>
+      <p:sp>
+        <p:nvSpPr>
+          <p:cNvPr id="9" name="Rectangle 8"/>
+          <p:cNvSpPr/>
+          <p:nvPr/>
+        </p:nvSpPr>
+        <p:spPr>
+          <a:xfrm>
+            <a:off x="457200" y="4434840"/>
+            <a:ext cx="8229600" cy="411480"/>
+          </a:xfrm>
+          <a:prstGeom prst="rect">
+            <a:avLst/>
+          </a:prstGeom>
+          <a:solidFill>
+            <a:srgbClr val="F3F4F6"/>
+          </a:solidFill>
+          <a:ln w="12700">
+            <a:solidFill>
+              <a:srgbClr val="F3F4F6"/>
+            </a:solidFill>
+          </a:ln>
+          <a:effectLst/>
+        </p:spPr>
+        <p:style>
+          <a:lnRef idx="1">
+            <a:schemeClr val="accent1"/>
+          </a:lnRef>
+          <a:fillRef idx="3">
+            <a:schemeClr val="accent1"/>
+          </a:fillRef>
+          <a:effectRef idx="2">
+            <a:schemeClr val="accent1"/>
+          </a:effectRef>
+          <a:fontRef idx="minor">
+            <a:schemeClr val="lt1"/>
+          </a:fontRef>
+        </p:style>
+        <p:txBody>
+          <a:bodyPr rtlCol="0" anchor="ctr"/>
+          <a:lstStyle/>
+          <a:p>
+            <a:pPr algn="ctr"/>
+          </a:p>
+        </p:txBody>
+      </p:sp>
+      <p:sp>
+        <p:nvSpPr>
+          <p:cNvPr id="10" name="Rectangle 9"/>
+          <p:cNvSpPr/>
+          <p:nvPr/>
+        </p:nvSpPr>
+        <p:spPr>
+          <a:xfrm>
+            <a:off x="457200" y="4434840"/>
+            <a:ext cx="73152" cy="411480"/>
+          </a:xfrm>
+          <a:prstGeom prst="rect">
+            <a:avLst/>
+          </a:prstGeom>
+          <a:solidFill>
+            <a:srgbClr val="15803D"/>
+          </a:solidFill>
+          <a:ln w="12700">
+            <a:solidFill>
+              <a:srgbClr val="15803D"/>
+            </a:solidFill>
+          </a:ln>
+          <a:effectLst/>
+        </p:spPr>
+        <p:style>
+          <a:lnRef idx="1">
+            <a:schemeClr val="accent1"/>
+          </a:lnRef>
+          <a:fillRef idx="3">
+            <a:schemeClr val="accent1"/>
+          </a:fillRef>
+          <a:effectRef idx="2">
+            <a:schemeClr val="accent1"/>
+          </a:effectRef>
+          <a:fontRef idx="minor">
+            <a:schemeClr val="lt1"/>
+          </a:fontRef>
+        </p:style>
+        <p:txBody>
+          <a:bodyPr rtlCol="0" anchor="ctr"/>
+          <a:lstStyle/>
+          <a:p>
+            <a:pPr algn="ctr"/>
+          </a:p>
+        </p:txBody>
+      </p:sp>
+      <p:sp>
+        <p:nvSpPr>
+          <p:cNvPr id="11" name="Rectangle 10"/>
+          <p:cNvSpPr/>
+          <p:nvPr/>
+        </p:nvSpPr>
+        <p:spPr>
+          <a:xfrm>
+            <a:off x="640080" y="4464840"/>
+            <a:ext cx="7955280" cy="200000"/>
+          </a:xfrm>
+          <a:prstGeom prst="rect">
+            <a:avLst/>
+          </a:prstGeom>
+          <a:noFill/>
+          <a:ln>
+            <a:noFill/>
+          </a:ln>
+          <a:effectLst/>
+        </p:spPr>
+        <p:style>
+          <a:lnRef idx="1">
+            <a:schemeClr val="accent1"/>
+          </a:lnRef>
+          <a:fillRef idx="3">
+            <a:schemeClr val="accent1"/>
+          </a:fillRef>
+          <a:effectRef idx="2">
+            <a:schemeClr val="accent1"/>
+          </a:effectRef>
+          <a:fontRef idx="minor">
+            <a:schemeClr val="lt1"/>
+          </a:fontRef>
+        </p:style>
+        <p:txBody>
+          <a:bodyPr rtlCol="0" anchor="ctr" lIns="0" tIns="0" rIns="0" bIns="0" wrap="square"/>
+          <a:lstStyle/>
+          <a:p>
+            <a:pPr algn="l">
+              <a:buNone/>
+            </a:pPr>
+            <a:r>
+              <a:rPr sz="1000" b="1" i="0">
+                <a:solidFill>
+                  <a:srgbClr val="15803D"/>
+                </a:solidFill>
+                <a:latin typeface="Arial"/>
+              </a:rPr>
+              <a:t>NEXT</a:t>
+            </a:r>
+          </a:p>
+        </p:txBody>
+      </p:sp>
+      <p:sp>
+        <p:nvSpPr>
+          <p:cNvPr id="12" name="Rectangle 11"/>
+          <p:cNvSpPr/>
+          <p:nvPr/>
+        </p:nvSpPr>
+        <p:spPr>
+          <a:xfrm>
+            <a:off x="640080" y="4644840"/>
+            <a:ext cx="7955280" cy="190000"/>
+          </a:xfrm>
+          <a:prstGeom prst="rect">
+            <a:avLst/>
+          </a:prstGeom>
+          <a:noFill/>
+          <a:ln>
+            <a:noFill/>
+          </a:ln>
+          <a:effectLst/>
+        </p:spPr>
+        <p:style>
+          <a:lnRef idx="1">
+            <a:schemeClr val="accent1"/>
+          </a:lnRef>
+          <a:fillRef idx="3">
+            <a:schemeClr val="accent1"/>
+          </a:fillRef>
+          <a:effectRef idx="2">
+            <a:schemeClr val="accent1"/>
+          </a:effectRef>
+          <a:fontRef idx="minor">
+            <a:schemeClr val="lt1"/>
+          </a:fontRef>
+        </p:style>
+        <p:txBody>
+          <a:bodyPr rtlCol="0" anchor="t" lIns="0" tIns="0" rIns="0" bIns="0" wrap="square"/>
+          <a:lstStyle/>
+          <a:p>
+            <a:pPr algn="l">
+              <a:buNone/>
+            </a:pPr>
+            <a:r>
+              <a:rPr sz="1000" b="0" i="0">
+                <a:solidFill>
+                  <a:srgbClr val="1F2937"/>
+                </a:solidFill>
+                <a:latin typeface="Arial"/>
+              </a:rPr>
+              <a:t>Day 3 — Dark web, crypto tracing &amp; endpoint forensics (memory analysis).</a:t>
+            </a:r>
+          </a:p>
+        </p:txBody>
+      </p:sp>
+    </p:spTree>
+  </p:cSld>
+  <p:clrMapOvr>
+    <a:masterClrMapping/>
+  </p:clrMapOvr>
+</p:sld>
+</file>
+
+<file path=ppt/slides/slide34.xml><?xml version="1.0" encoding="utf-8"?>
+<p:sld xmlns:a="http://schemas.openxmlformats.org/drawingml/2006/main" xmlns:p="http://schemas.openxmlformats.org/presentationml/2006/main" xmlns:r="http://schemas.openxmlformats.org/officeDocument/2006/relationships">
+  <p:cSld>
+    <p:spTree>
+      <p:nvGrpSpPr>
+        <p:cNvPr id="1" name=""/>
+        <p:cNvGrpSpPr/>
+        <p:nvPr/>
+      </p:nvGrpSpPr>
+      <p:grpSpPr/>
+      <p:pic>
+        <p:nvPicPr>
+          <p:cNvPr id="2" name="Picture 1" descr="ascent.png"/>
+          <p:cNvPicPr>
+            <a:picLocks noChangeAspect="1"/>
+          </p:cNvPicPr>
+          <p:nvPr/>
+        </p:nvPicPr>
+        <p:blipFill>
+          <a:blip r:embed="rId2"/>
+          <a:stretch>
+            <a:fillRect/>
+          </a:stretch>
+        </p:blipFill>
+        <p:spPr>
+          <a:xfrm>
+            <a:off x="8321040" y="228600"/>
+            <a:ext cx="502920" cy="502920"/>
+          </a:xfrm>
+          <a:prstGeom prst="rect">
+            <a:avLst/>
+          </a:prstGeom>
+        </p:spPr>
+      </p:pic>
+      <p:sp>
+        <p:nvSpPr>
+          <p:cNvPr id="3" name="Rectangle 2"/>
+          <p:cNvSpPr/>
+          <p:nvPr/>
+        </p:nvSpPr>
+        <p:spPr>
+          <a:xfrm>
+            <a:off x="457200" y="256032"/>
+            <a:ext cx="7669600" cy="228600"/>
+          </a:xfrm>
+          <a:prstGeom prst="rect">
+            <a:avLst/>
+          </a:prstGeom>
+          <a:noFill/>
+          <a:ln>
+            <a:noFill/>
+          </a:ln>
+          <a:effectLst/>
+        </p:spPr>
+        <p:style>
+          <a:lnRef idx="1">
+            <a:schemeClr val="accent1"/>
+          </a:lnRef>
+          <a:fillRef idx="3">
+            <a:schemeClr val="accent1"/>
+          </a:fillRef>
+          <a:effectRef idx="2">
+            <a:schemeClr val="accent1"/>
+          </a:effectRef>
+          <a:fontRef idx="minor">
+            <a:schemeClr val="lt1"/>
+          </a:fontRef>
+        </p:style>
+        <p:txBody>
+          <a:bodyPr rtlCol="0" anchor="ctr" lIns="0" tIns="0" rIns="0" bIns="0" wrap="square"/>
+          <a:lstStyle/>
+          <a:p>
+            <a:pPr algn="l">
+              <a:buNone/>
+            </a:pPr>
+            <a:r>
+              <a:rPr sz="1000" b="0" i="0">
+                <a:solidFill>
+                  <a:srgbClr val="6B7280"/>
+                </a:solidFill>
+                <a:latin typeface="Arial"/>
+              </a:rPr>
+              <a:t>LAB - TP 2</a:t>
+            </a:r>
+          </a:p>
+        </p:txBody>
+      </p:sp>
+      <p:sp>
+        <p:nvSpPr>
+          <p:cNvPr id="4" name="Rectangle 3"/>
+          <p:cNvSpPr/>
+          <p:nvPr/>
+        </p:nvSpPr>
+        <p:spPr>
+          <a:xfrm>
+            <a:off x="457200" y="475488"/>
+            <a:ext cx="8229600" cy="502920"/>
+          </a:xfrm>
+          <a:prstGeom prst="rect">
+            <a:avLst/>
+          </a:prstGeom>
+          <a:noFill/>
+          <a:ln>
+            <a:noFill/>
+          </a:ln>
+          <a:effectLst/>
+        </p:spPr>
+        <p:style>
+          <a:lnRef idx="1">
+            <a:schemeClr val="accent1"/>
+          </a:lnRef>
+          <a:fillRef idx="3">
+            <a:schemeClr val="accent1"/>
+          </a:fillRef>
+          <a:effectRef idx="2">
+            <a:schemeClr val="accent1"/>
+          </a:effectRef>
+          <a:fontRef idx="minor">
+            <a:schemeClr val="lt1"/>
+          </a:fontRef>
+        </p:style>
+        <p:txBody>
+          <a:bodyPr rtlCol="0" anchor="t" lIns="0" tIns="0" rIns="0" bIns="0" wrap="square"/>
+          <a:lstStyle/>
+          <a:p>
+            <a:pPr algn="l">
+              <a:buNone/>
+            </a:pPr>
+            <a:r>
+              <a:rPr sz="2200" b="1" i="0">
+                <a:solidFill>
+                  <a:srgbClr val="1F2937"/>
+                </a:solidFill>
+                <a:latin typeface="Arial"/>
+              </a:rPr>
+              <a:t>API Scraping - intercept &amp; replay</a:t>
+            </a:r>
+          </a:p>
+        </p:txBody>
+      </p:sp>
+      <p:sp>
+        <p:nvSpPr>
+          <p:cNvPr id="5" name="Rectangle 4"/>
+          <p:cNvSpPr/>
+          <p:nvPr/>
+        </p:nvSpPr>
+        <p:spPr>
+          <a:xfrm>
+            <a:off x="457200" y="1024128"/>
+            <a:ext cx="548640" cy="27432"/>
+          </a:xfrm>
+          <a:prstGeom prst="rect">
+            <a:avLst/>
+          </a:prstGeom>
+          <a:solidFill>
+            <a:srgbClr val="1E40AF"/>
+          </a:solidFill>
+          <a:ln w="12700">
+            <a:solidFill>
+              <a:srgbClr val="1E40AF"/>
+            </a:solidFill>
+          </a:ln>
+          <a:effectLst/>
+        </p:spPr>
+        <p:style>
+          <a:lnRef idx="1">
+            <a:schemeClr val="accent1"/>
+          </a:lnRef>
+          <a:fillRef idx="3">
+            <a:schemeClr val="accent1"/>
+          </a:fillRef>
+          <a:effectRef idx="2">
+            <a:schemeClr val="accent1"/>
+          </a:effectRef>
+          <a:fontRef idx="minor">
+            <a:schemeClr val="lt1"/>
+          </a:fontRef>
+        </p:style>
+        <p:txBody>
+          <a:bodyPr rtlCol="0" anchor="ctr"/>
+          <a:lstStyle/>
+          <a:p>
+            <a:pPr algn="ctr"/>
+          </a:p>
+        </p:txBody>
+      </p:sp>
+      <p:sp>
+        <p:nvSpPr>
+          <p:cNvPr id="6" name="Rectangle 5"/>
+          <p:cNvSpPr/>
+          <p:nvPr/>
+        </p:nvSpPr>
+        <p:spPr>
+          <a:xfrm>
+            <a:off x="457200" y="4823460"/>
+            <a:ext cx="4572000" cy="228600"/>
+          </a:xfrm>
+          <a:prstGeom prst="rect">
+            <a:avLst/>
+          </a:prstGeom>
+          <a:noFill/>
+          <a:ln>
+            <a:noFill/>
+          </a:ln>
+          <a:effectLst/>
+        </p:spPr>
+        <p:style>
+          <a:lnRef idx="1">
+            <a:schemeClr val="accent1"/>
+          </a:lnRef>
+          <a:fillRef idx="3">
+            <a:schemeClr val="accent1"/>
+          </a:fillRef>
+          <a:effectRef idx="2">
+            <a:schemeClr val="accent1"/>
+          </a:effectRef>
+          <a:fontRef idx="minor">
+            <a:schemeClr val="lt1"/>
+          </a:fontRef>
+        </p:style>
+        <p:txBody>
+          <a:bodyPr rtlCol="0" anchor="ctr" lIns="0" tIns="0" rIns="0" bIns="0" wrap="square"/>
+          <a:lstStyle/>
+          <a:p>
+            <a:pPr algn="l">
+              <a:buNone/>
+            </a:pPr>
+            <a:r>
+              <a:rPr sz="900" b="0" i="0">
+                <a:solidFill>
+                  <a:srgbClr val="6B7280"/>
+                </a:solidFill>
+                <a:latin typeface="Arial"/>
+              </a:rPr>
+              <a:t>Forensics &amp; OSINT Advanced  -  Day 2 / 3</a:t>
+            </a:r>
+          </a:p>
+        </p:txBody>
+      </p:sp>
+      <p:sp>
+        <p:nvSpPr>
+          <p:cNvPr id="7" name="Rectangle 6"/>
+          <p:cNvSpPr/>
+          <p:nvPr/>
+        </p:nvSpPr>
+        <p:spPr>
+          <a:xfrm>
+            <a:off x="457200" y="1188720"/>
+            <a:ext cx="8229600" cy="548640"/>
+          </a:xfrm>
+          <a:prstGeom prst="rect">
+            <a:avLst/>
+          </a:prstGeom>
+          <a:noFill/>
+          <a:ln>
+            <a:noFill/>
+          </a:ln>
+          <a:effectLst/>
+        </p:spPr>
+        <p:style>
+          <a:lnRef idx="1">
+            <a:schemeClr val="accent1"/>
+          </a:lnRef>
+          <a:fillRef idx="3">
+            <a:schemeClr val="accent1"/>
+          </a:fillRef>
+          <a:effectRef idx="2">
+            <a:schemeClr val="accent1"/>
+          </a:effectRef>
+          <a:fontRef idx="minor">
+            <a:schemeClr val="lt1"/>
+          </a:fontRef>
+        </p:style>
+        <p:txBody>
+          <a:bodyPr rtlCol="0" anchor="ctr" lIns="0" tIns="0" rIns="0" bIns="0" wrap="square"/>
+          <a:lstStyle/>
+          <a:p>
+            <a:pPr algn="l">
+              <a:buNone/>
+            </a:pPr>
+            <a:r>
+              <a:rPr sz="1300" b="0" i="1">
+                <a:solidFill>
+                  <a:srgbClr val="1F2937"/>
+                </a:solidFill>
+                <a:latin typeface="Arial"/>
+              </a:rPr>
+              <a:t>Capture the real session in Burp, find the product/stock endpoint, then scale it in Python.</a:t>
             </a:r>
           </a:p>
         </p:txBody>
@@ -20750,11 +21453,11 @@
             <a:r>
               <a:rPr sz="1050" b="0" i="0">
                 <a:solidFill>
-                  <a:srgbClr val="1F2937"/>
+                  <a:srgbClr val="6B7280"/>
                 </a:solidFill>
                 <a:latin typeface="Consolas"/>
               </a:rPr>
-              <a:t>import pandas as pd, difflib</a:t>
+              <a:t># 1) Burp: browse the site, find the product endpoint in HTTP history</a:t>
             </a:r>
           </a:p>
           <a:p>
@@ -20767,11 +21470,11 @@
             <a:r>
               <a:rPr sz="1050" b="0" i="0">
                 <a:solidFill>
-                  <a:srgbClr val="1F2937"/>
+                  <a:srgbClr val="6B7280"/>
                 </a:solidFill>
                 <a:latin typeface="Consolas"/>
               </a:rPr>
-              <a:t>df = pd.read_csv("accounts.csv")</a:t>
+              <a:t># 2) read its request: params (pagination), Authorization: Bearer, cookies</a:t>
             </a:r>
           </a:p>
           <a:p>
@@ -20784,11 +21487,11 @@
             <a:r>
               <a:rPr sz="1050" b="0" i="0">
                 <a:solidFill>
-                  <a:srgbClr val="1F2937"/>
+                  <a:srgbClr val="6B7280"/>
                 </a:solidFill>
                 <a:latin typeface="Consolas"/>
               </a:rPr>
-              <a:t>df["ts"] = pd.to_datetime(df["timestamp"], utc=True)</a:t>
+              <a:t># 3) replay &amp; paginate it in Python (requests)</a:t>
             </a:r>
           </a:p>
           <a:p>
@@ -20805,7 +21508,7 @@
                 </a:solidFill>
                 <a:latin typeface="Consolas"/>
               </a:rPr>
-              <a:t/>
+              <a:t>s = requests.Session(); s.headers["Authorization"] = f"Bearer {token}"</a:t>
             </a:r>
           </a:p>
           <a:p>
@@ -20818,11 +21521,11 @@
             <a:r>
               <a:rPr sz="1050" b="0" i="0">
                 <a:solidFill>
-                  <a:srgbClr val="6B7280"/>
+                  <a:srgbClr val="1F2937"/>
                 </a:solidFill>
                 <a:latin typeface="Consolas"/>
               </a:rPr>
-              <a:t># Creation burst + post synchronisation</a:t>
+              <a:t>while start &lt; total:</a:t>
             </a:r>
           </a:p>
           <a:p>
@@ -20839,7 +21542,7 @@
                 </a:solidFill>
                 <a:latin typeface="Consolas"/>
               </a:rPr>
-              <a:t>df["creation_date"].value_counts().head()</a:t>
+              <a:t>    hits += s.get(url, params={"c_start": start, "c_sz": 48}).json()["hits"]</a:t>
             </a:r>
           </a:p>
           <a:p>
@@ -20856,7 +21559,7 @@
                 </a:solidFill>
                 <a:latin typeface="Consolas"/>
               </a:rPr>
-              <a:t>df.groupby(df["ts"].dt.floor("min")).size().sort_values(ascending=False).head()</a:t>
+              <a:t>    start += 48</a:t>
             </a:r>
           </a:p>
           <a:p>
@@ -20873,41 +21576,7 @@
                 </a:solidFill>
                 <a:latin typeface="Consolas"/>
               </a:rPr>
-              <a:t/>
-            </a:r>
-          </a:p>
-          <a:p>
-            <a:pPr algn="l">
-              <a:lnSpc>
-                <a:spcPct val="102000"/>
-              </a:lnSpc>
-              <a:buNone/>
-            </a:pPr>
-            <a:r>
-              <a:rPr sz="1050" b="0" i="0">
-                <a:solidFill>
-                  <a:srgbClr val="6B7280"/>
-                </a:solidFill>
-                <a:latin typeface="Consolas"/>
-              </a:rPr>
-              <a:t># Near-duplicate text (similarity &gt; 0.85)</a:t>
-            </a:r>
-          </a:p>
-          <a:p>
-            <a:pPr algn="l">
-              <a:lnSpc>
-                <a:spcPct val="102000"/>
-              </a:lnSpc>
-              <a:buNone/>
-            </a:pPr>
-            <a:r>
-              <a:rPr sz="1050" b="0" i="0">
-                <a:solidFill>
-                  <a:srgbClr val="1F2937"/>
-                </a:solidFill>
-                <a:latin typeface="Consolas"/>
-              </a:rPr>
-              <a:t>difflib.SequenceMatcher(None, t_i, t_j).ratio()</a:t>
+              <a:t>pd.json_normalize(hits).to_csv("products.csv", index=False)</a:t>
             </a:r>
           </a:p>
         </p:txBody>
@@ -20973,11 +21642,11 @@
             <a:avLst/>
           </a:prstGeom>
           <a:solidFill>
-            <a:srgbClr val="1E40AF"/>
+            <a:srgbClr val="B45309"/>
           </a:solidFill>
           <a:ln w="12700">
             <a:solidFill>
-              <a:srgbClr val="1E40AF"/>
+              <a:srgbClr val="B45309"/>
             </a:solidFill>
           </a:ln>
           <a:effectLst/>
@@ -21048,11 +21717,11 @@
             <a:r>
               <a:rPr sz="1000" b="1" i="0">
                 <a:solidFill>
-                  <a:srgbClr val="1E40AF"/>
-                </a:solidFill>
-                <a:latin typeface="Arial"/>
-              </a:rPr>
-              <a:t>WEIGHT OF EVIDENCE</a:t>
+                  <a:srgbClr val="B45309"/>
+                </a:solidFill>
+                <a:latin typeface="Arial"/>
+              </a:rPr>
+              <a:t>METHOD</a:t>
             </a:r>
           </a:p>
         </p:txBody>
@@ -21105,7 +21774,7 @@
                 </a:solidFill>
                 <a:latin typeface="Arial"/>
               </a:rPr>
-              <a:t>Metadata, ELA, shadows, reverse image, C2PA, video cuts, CIB - converge, never one test.</a:t>
+              <a:t>Burp to capture, Python to scale. Same steps for an API found via Shodan (authorised only).</a:t>
             </a:r>
           </a:p>
         </p:txBody>

</xml_diff>

<commit_message>
Day 3 overhaul: STIX Lab (beginner->expert), deck rebuild, Data Breach -> Day 3
- Rebuild the Day 3 deck around blockchain fundamentals, crypto tracing, STIX & MITRE
  ATT&CK (~1/3 of the deck) and agentic automation; dark web reduced to 2 slides.
- Add Day_3/STIX Lab: build/validate a STIX 2.1 bundle, OSINT->STIX, parallel agents,
  team graph dashboard, n8n workflow, and advanced modules (validate, Admiralty<->STIX,
  diff-monitor, ATT&CK enrichment, OpenCTI/TAXII).
- Add Day_3/Corporate Watch Lab (aggregate CI monitor).
- Move Databreach.pdf from Day 2 to Day 3; drop the Data Breach TP from the Day 2 deck.
- Update the student handbook README and .gitignore.
</commit_message>
<xml_diff>
--- a/Day_2/Day_2_Source_Reliability_And_Media_Forensics.pptx
+++ b/Day_2/Day_2_Source_Reliability_And_Media_Forensics.pptx
@@ -36,7 +36,6 @@
     <p:sldId id="284" r:id="rId35"/>
     <p:sldId id="289" r:id="rId40"/>
     <p:sldId id="285" r:id="rId36"/>
-    <p:sldId id="288" r:id="rId39"/>
     <p:sldId id="286" r:id="rId37"/>
     <p:sldId id="287" r:id="rId38"/>
   </p:sldIdLst>
@@ -17009,7 +17008,7 @@
                           </a:solidFill>
                           <a:latin typeface="Arial"/>
                         </a:rPr>
-                        <a:t>4</a:t>
+                        <a:t>Deliverable</a:t>
                       </a:r>
                     </a:p>
                   </a:txBody>
@@ -17032,7 +17031,7 @@
                           </a:solidFill>
                           <a:latin typeface="Arial"/>
                         </a:rPr>
-                        <a:t>Data Breach - leaked SQL dump, Python/pandas analysis</a:t>
+                        <a:t>One sourced note per TP: findings + Admiralty rating + provenance</a:t>
                       </a:r>
                     </a:p>
                   </a:txBody>
@@ -17055,7 +17054,7 @@
                           </a:solidFill>
                           <a:latin typeface="Arial"/>
                         </a:rPr>
-                        <a:t>75 min</a:t>
+                        <a:t>-</a:t>
                       </a:r>
                     </a:p>
                   </a:txBody>
@@ -17080,7 +17079,7 @@
                           </a:solidFill>
                           <a:latin typeface="Arial"/>
                         </a:rPr>
-                        <a:t>Deliverable</a:t>
+                        <a:t>Toolbox</a:t>
                       </a:r>
                     </a:p>
                   </a:txBody>
@@ -17103,7 +17102,7 @@
                           </a:solidFill>
                           <a:latin typeface="Arial"/>
                         </a:rPr>
-                        <a:t>One sourced note per TP: findings + Admiralty rating + provenance</a:t>
+                        <a:t>Cheat sheets: Linux basics, Bash scripting, Kali/OSINT tools</a:t>
                       </a:r>
                     </a:p>
                   </a:txBody>
@@ -18485,7 +18484,7 @@
                           </a:solidFill>
                           <a:latin typeface="Arial"/>
                         </a:rPr>
-                        <a:t>Geosint + Data Breach, with Admiralty-rated notes</a:t>
+                        <a:t>Geosint - geolocation &amp; chronolocation</a:t>
                       </a:r>
                     </a:p>
                   </a:txBody>
@@ -18613,7 +18612,7 @@
                 </a:solidFill>
                 <a:latin typeface="Arial"/>
               </a:rPr>
-              <a:t>LAB - TP 3</a:t>
+              <a:t>LAB - TP 2</a:t>
             </a:r>
           </a:p>
         </p:txBody>
@@ -18666,7 +18665,7 @@
                 </a:solidFill>
                 <a:latin typeface="Arial"/>
               </a:rPr>
-              <a:t>Geosint - Operation Glass Eye</a:t>
+              <a:t>API Scraping - intercept &amp; replay</a:t>
             </a:r>
           </a:p>
         </p:txBody>
@@ -18818,7 +18817,7 @@
                 </a:solidFill>
                 <a:latin typeface="Arial"/>
               </a:rPr>
-              <a:t>Geolocate a drone's last transmitted frame, then chronolocate it with the sun.</a:t>
+              <a:t>Capture the real session in Burp, find the product/stock endpoint, then scale it in Python.</a:t>
             </a:r>
           </a:p>
         </p:txBody>
@@ -18920,7 +18919,7 @@
                 </a:solidFill>
                 <a:latin typeface="Consolas"/>
               </a:rPr>
-              <a:t># Chain of custody first (Seq. 1)</a:t>
+              <a:t># 1) Burp: browse the site, find the product endpoint in HTTP history</a:t>
             </a:r>
           </a:p>
           <a:p>
@@ -18933,11 +18932,11 @@
             <a:r>
               <a:rPr sz="1050" b="0" i="0">
                 <a:solidFill>
-                  <a:srgbClr val="1F2937"/>
+                  <a:srgbClr val="6B7280"/>
                 </a:solidFill>
                 <a:latin typeface="Consolas"/>
               </a:rPr>
-              <a:t>sha256sum last_frame.jpg ; exiftool -a -G1 last_frame.jpg</a:t>
+              <a:t># 2) read its request: params (pagination), Authorization: Bearer, cookies</a:t>
             </a:r>
           </a:p>
           <a:p>
@@ -18950,11 +18949,11 @@
             <a:r>
               <a:rPr sz="1050" b="0" i="0">
                 <a:solidFill>
-                  <a:srgbClr val="1F2937"/>
+                  <a:srgbClr val="6B7280"/>
                 </a:solidFill>
                 <a:latin typeface="Consolas"/>
               </a:rPr>
-              <a:t/>
+              <a:t># 3) replay &amp; paginate it in Python (requests)</a:t>
             </a:r>
           </a:p>
           <a:p>
@@ -18967,11 +18966,11 @@
             <a:r>
               <a:rPr sz="1050" b="0" i="0">
                 <a:solidFill>
-                  <a:srgbClr val="6B7280"/>
+                  <a:srgbClr val="1F2937"/>
                 </a:solidFill>
                 <a:latin typeface="Consolas"/>
               </a:rPr>
-              <a:t># Enumerate candidates near the launch point (OpenStreetMap / Overpass)</a:t>
+              <a:t>s = requests.Session(); s.headers["Authorization"] = f"Bearer {token}"</a:t>
             </a:r>
           </a:p>
           <a:p>
@@ -18988,7 +18987,7 @@
                 </a:solidFill>
                 <a:latin typeface="Consolas"/>
               </a:rPr>
-              <a:t>curl -s https://overpass-api.de/api/interpreter --data-urlencode \</a:t>
+              <a:t>while start &lt; total:</a:t>
             </a:r>
           </a:p>
           <a:p>
@@ -19005,7 +19004,7 @@
                 </a:solidFill>
                 <a:latin typeface="Consolas"/>
               </a:rPr>
-              <a:t>  'data=[out:csv(::lat,::lon)];node["generator:source"="wind"](around:8000,47.5988,-1.1389);out;'</a:t>
+              <a:t>    hits += s.get(url, params={"c_start": start, "c_sz": 48}).json()["hits"]</a:t>
             </a:r>
           </a:p>
           <a:p>
@@ -19022,7 +19021,7 @@
                 </a:solidFill>
                 <a:latin typeface="Consolas"/>
               </a:rPr>
-              <a:t/>
+              <a:t>    start += 48</a:t>
             </a:r>
           </a:p>
           <a:p>
@@ -19035,11 +19034,11 @@
             <a:r>
               <a:rPr sz="1050" b="0" i="0">
                 <a:solidFill>
-                  <a:srgbClr val="6B7280"/>
+                  <a:srgbClr val="1F2937"/>
                 </a:solidFill>
                 <a:latin typeface="Consolas"/>
               </a:rPr>
-              <a:t># Chronolocate: shadow direction + sun position  -&gt; SunCalc</a:t>
+              <a:t>pd.json_normalize(hits).to_csv("products.csv", index=False)</a:t>
             </a:r>
           </a:p>
         </p:txBody>
@@ -19105,11 +19104,11 @@
             <a:avLst/>
           </a:prstGeom>
           <a:solidFill>
-            <a:srgbClr val="1E40AF"/>
+            <a:srgbClr val="B45309"/>
           </a:solidFill>
           <a:ln w="12700">
             <a:solidFill>
-              <a:srgbClr val="1E40AF"/>
+              <a:srgbClr val="B45309"/>
             </a:solidFill>
           </a:ln>
           <a:effectLst/>
@@ -19180,11 +19179,11 @@
             <a:r>
               <a:rPr sz="1000" b="1" i="0">
                 <a:solidFill>
-                  <a:srgbClr val="1E40AF"/>
-                </a:solidFill>
-                <a:latin typeface="Arial"/>
-              </a:rPr>
-              <a:t>APPLIES - Seq. 3</a:t>
+                  <a:srgbClr val="B45309"/>
+                </a:solidFill>
+                <a:latin typeface="Arial"/>
+              </a:rPr>
+              <a:t>METHOD</a:t>
             </a:r>
           </a:p>
         </p:txBody>
@@ -19237,7 +19236,7 @@
                 </a:solidFill>
                 <a:latin typeface="Arial"/>
               </a:rPr>
-              <a:t>Geolocation &amp; chronolocation. Rate every finding with the Admiralty scale.</a:t>
+              <a:t>Burp to capture, Python to scale. Same steps for an API found via Shodan (authorised only).</a:t>
             </a:r>
           </a:p>
         </p:txBody>
@@ -19332,7 +19331,7 @@
                 </a:solidFill>
                 <a:latin typeface="Arial"/>
               </a:rPr>
-              <a:t>LAB - TP 4</a:t>
+              <a:t>LAB - TP 3</a:t>
             </a:r>
           </a:p>
         </p:txBody>
@@ -19385,7 +19384,7 @@
                 </a:solidFill>
                 <a:latin typeface="Arial"/>
               </a:rPr>
-              <a:t>Data Breach - dump analysis</a:t>
+              <a:t>Geosint - Operation Glass Eye</a:t>
             </a:r>
           </a:p>
         </p:txBody>
@@ -19537,7 +19536,7 @@
                 </a:solidFill>
                 <a:latin typeface="Arial"/>
               </a:rPr>
-              <a:t>Load a leaked SQL dump locally, map its schema, quantify the exposure with Python.</a:t>
+              <a:t>Geolocate a drone's last transmitted frame, then chronolocate it with the sun.</a:t>
             </a:r>
           </a:p>
         </p:txBody>
@@ -19639,7 +19638,7 @@
                 </a:solidFill>
                 <a:latin typeface="Consolas"/>
               </a:rPr>
-              <a:t># Leaked SQL dump -&gt; local DB -&gt; READ-ONLY analysis (SQLAlchemy + pandas)</a:t>
+              <a:t># Chain of custody first (Seq. 1)</a:t>
             </a:r>
           </a:p>
           <a:p>
@@ -19656,7 +19655,7 @@
                 </a:solidFill>
                 <a:latin typeface="Consolas"/>
               </a:rPr>
-              <a:t>from sqlalchemy import create_engine; import pandas as pd</a:t>
+              <a:t>sha256sum last_frame.jpg ; exiftool -a -G1 last_frame.jpg</a:t>
             </a:r>
           </a:p>
           <a:p>
@@ -19673,7 +19672,7 @@
                 </a:solidFill>
                 <a:latin typeface="Consolas"/>
               </a:rPr>
-              <a:t>eng = create_engine("mysql+pymysql://user:pw@127.0.0.1:3306/leak")</a:t>
+              <a:t/>
             </a:r>
           </a:p>
           <a:p>
@@ -19686,11 +19685,11 @@
             <a:r>
               <a:rPr sz="1050" b="0" i="0">
                 <a:solidFill>
-                  <a:srgbClr val="1F2937"/>
+                  <a:srgbClr val="6B7280"/>
                 </a:solidFill>
                 <a:latin typeface="Consolas"/>
               </a:rPr>
-              <a:t>pd.read_sql("SELECT COUNT(*) FROM information_schema.tables "</a:t>
+              <a:t># Enumerate candidates near the launch point (OpenStreetMap / Overpass)</a:t>
             </a:r>
           </a:p>
           <a:p>
@@ -19707,7 +19706,7 @@
                 </a:solidFill>
                 <a:latin typeface="Consolas"/>
               </a:rPr>
-              <a:t>            "WHERE table_schema=DATABASE()", eng)      # map the schema</a:t>
+              <a:t>curl -s https://overpass-api.de/api/interpreter --data-urlencode \</a:t>
             </a:r>
           </a:p>
           <a:p>
@@ -19724,7 +19723,7 @@
                 </a:solidFill>
                 <a:latin typeface="Consolas"/>
               </a:rPr>
-              <a:t>df = pd.read_sql("SELECT email, created FROM users", eng)  # extract &amp; aggregate</a:t>
+              <a:t>  'data=[out:csv(::lat,::lon)];node["generator:source"="wind"](around:8000,47.5988,-1.1389);out;'</a:t>
             </a:r>
           </a:p>
           <a:p>
@@ -19741,7 +19740,24 @@
                 </a:solidFill>
                 <a:latin typeface="Consolas"/>
               </a:rPr>
-              <a:t>df.to_csv("exposure.csv", index=False)                 # export (anonymised)</a:t>
+              <a:t/>
+            </a:r>
+          </a:p>
+          <a:p>
+            <a:pPr algn="l">
+              <a:lnSpc>
+                <a:spcPct val="102000"/>
+              </a:lnSpc>
+              <a:buNone/>
+            </a:pPr>
+            <a:r>
+              <a:rPr sz="1050" b="0" i="0">
+                <a:solidFill>
+                  <a:srgbClr val="6B7280"/>
+                </a:solidFill>
+                <a:latin typeface="Consolas"/>
+              </a:rPr>
+              <a:t># Chronolocate: shadow direction + sun position  -&gt; SunCalc</a:t>
             </a:r>
           </a:p>
         </p:txBody>
@@ -19886,7 +19902,7 @@
                 </a:solidFill>
                 <a:latin typeface="Arial"/>
               </a:rPr>
-              <a:t>GDPR</a:t>
+              <a:t>APPLIES - Seq. 3</a:t>
             </a:r>
           </a:p>
         </p:txBody>
@@ -19939,442 +19955,7 @@
                 </a:solidFill>
                 <a:latin typeface="Arial"/>
               </a:rPr>
-              <a:t>Read-only. Anonymise output, never re-identify. Assess and report the exposure.</a:t>
-            </a:r>
-          </a:p>
-        </p:txBody>
-      </p:sp>
-    </p:spTree>
-  </p:cSld>
-  <p:clrMapOvr>
-    <a:masterClrMapping/>
-  </p:clrMapOvr>
-</p:sld>
-</file>
-
-<file path=ppt/slides/slide32.xml><?xml version="1.0" encoding="utf-8"?>
-<p:sld xmlns:a="http://schemas.openxmlformats.org/drawingml/2006/main" xmlns:p="http://schemas.openxmlformats.org/presentationml/2006/main" xmlns:r="http://schemas.openxmlformats.org/officeDocument/2006/relationships">
-  <p:cSld>
-    <p:spTree>
-      <p:nvGrpSpPr>
-        <p:cNvPr id="1" name=""/>
-        <p:cNvGrpSpPr/>
-        <p:nvPr/>
-      </p:nvGrpSpPr>
-      <p:grpSpPr/>
-      <p:pic>
-        <p:nvPicPr>
-          <p:cNvPr id="2" name="Picture 1" descr="ascent.png"/>
-          <p:cNvPicPr>
-            <a:picLocks noChangeAspect="1"/>
-          </p:cNvPicPr>
-          <p:nvPr/>
-        </p:nvPicPr>
-        <p:blipFill>
-          <a:blip r:embed="rId2"/>
-          <a:stretch>
-            <a:fillRect/>
-          </a:stretch>
-        </p:blipFill>
-        <p:spPr>
-          <a:xfrm>
-            <a:off x="8321040" y="228600"/>
-            <a:ext cx="502920" cy="502920"/>
-          </a:xfrm>
-          <a:prstGeom prst="rect">
-            <a:avLst/>
-          </a:prstGeom>
-        </p:spPr>
-      </p:pic>
-      <p:sp>
-        <p:nvSpPr>
-          <p:cNvPr id="3" name="Rectangle 2"/>
-          <p:cNvSpPr/>
-          <p:nvPr/>
-        </p:nvSpPr>
-        <p:spPr>
-          <a:xfrm>
-            <a:off x="457200" y="256032"/>
-            <a:ext cx="7669600" cy="228600"/>
-          </a:xfrm>
-          <a:prstGeom prst="rect">
-            <a:avLst/>
-          </a:prstGeom>
-          <a:noFill/>
-          <a:ln>
-            <a:noFill/>
-          </a:ln>
-          <a:effectLst/>
-        </p:spPr>
-        <p:style>
-          <a:lnRef idx="1">
-            <a:schemeClr val="accent1"/>
-          </a:lnRef>
-          <a:fillRef idx="3">
-            <a:schemeClr val="accent1"/>
-          </a:fillRef>
-          <a:effectRef idx="2">
-            <a:schemeClr val="accent1"/>
-          </a:effectRef>
-          <a:fontRef idx="minor">
-            <a:schemeClr val="lt1"/>
-          </a:fontRef>
-        </p:style>
-        <p:txBody>
-          <a:bodyPr rtlCol="0" anchor="ctr" lIns="0" tIns="0" rIns="0" bIns="0" wrap="square"/>
-          <a:lstStyle/>
-          <a:p>
-            <a:pPr algn="l">
-              <a:buNone/>
-            </a:pPr>
-            <a:r>
-              <a:rPr sz="1000" b="0" i="0">
-                <a:solidFill>
-                  <a:srgbClr val="6B7280"/>
-                </a:solidFill>
-                <a:latin typeface="Arial"/>
-              </a:rPr>
-              <a:t>LAB — AFTERNOON</a:t>
-            </a:r>
-          </a:p>
-        </p:txBody>
-      </p:sp>
-      <p:sp>
-        <p:nvSpPr>
-          <p:cNvPr id="4" name="Rectangle 3"/>
-          <p:cNvSpPr/>
-          <p:nvPr/>
-        </p:nvSpPr>
-        <p:spPr>
-          <a:xfrm>
-            <a:off x="457200" y="475488"/>
-            <a:ext cx="8229600" cy="502920"/>
-          </a:xfrm>
-          <a:prstGeom prst="rect">
-            <a:avLst/>
-          </a:prstGeom>
-          <a:noFill/>
-          <a:ln>
-            <a:noFill/>
-          </a:ln>
-          <a:effectLst/>
-        </p:spPr>
-        <p:style>
-          <a:lnRef idx="1">
-            <a:schemeClr val="accent1"/>
-          </a:lnRef>
-          <a:fillRef idx="3">
-            <a:schemeClr val="accent1"/>
-          </a:fillRef>
-          <a:effectRef idx="2">
-            <a:schemeClr val="accent1"/>
-          </a:effectRef>
-          <a:fontRef idx="minor">
-            <a:schemeClr val="lt1"/>
-          </a:fontRef>
-        </p:style>
-        <p:txBody>
-          <a:bodyPr rtlCol="0" anchor="t" lIns="0" tIns="0" rIns="0" bIns="0" wrap="square"/>
-          <a:lstStyle/>
-          <a:p>
-            <a:pPr algn="l">
-              <a:buNone/>
-            </a:pPr>
-            <a:r>
-              <a:rPr sz="2200" b="1" i="0">
-                <a:solidFill>
-                  <a:srgbClr val="1F2937"/>
-                </a:solidFill>
-                <a:latin typeface="Arial"/>
-              </a:rPr>
-              <a:t>Deliverable: sourced note (Admiralty)</a:t>
-            </a:r>
-          </a:p>
-        </p:txBody>
-      </p:sp>
-      <p:sp>
-        <p:nvSpPr>
-          <p:cNvPr id="5" name="Rectangle 4"/>
-          <p:cNvSpPr/>
-          <p:nvPr/>
-        </p:nvSpPr>
-        <p:spPr>
-          <a:xfrm>
-            <a:off x="457200" y="1024128"/>
-            <a:ext cx="548640" cy="27432"/>
-          </a:xfrm>
-          <a:prstGeom prst="rect">
-            <a:avLst/>
-          </a:prstGeom>
-          <a:solidFill>
-            <a:srgbClr val="1E40AF"/>
-          </a:solidFill>
-          <a:ln w="12700">
-            <a:solidFill>
-              <a:srgbClr val="1E40AF"/>
-            </a:solidFill>
-          </a:ln>
-          <a:effectLst/>
-        </p:spPr>
-        <p:style>
-          <a:lnRef idx="1">
-            <a:schemeClr val="accent1"/>
-          </a:lnRef>
-          <a:fillRef idx="3">
-            <a:schemeClr val="accent1"/>
-          </a:fillRef>
-          <a:effectRef idx="2">
-            <a:schemeClr val="accent1"/>
-          </a:effectRef>
-          <a:fontRef idx="minor">
-            <a:schemeClr val="lt1"/>
-          </a:fontRef>
-        </p:style>
-        <p:txBody>
-          <a:bodyPr rtlCol="0" anchor="ctr"/>
-          <a:lstStyle/>
-          <a:p>
-            <a:pPr algn="ctr"/>
-          </a:p>
-        </p:txBody>
-      </p:sp>
-      <p:sp>
-        <p:nvSpPr>
-          <p:cNvPr id="6" name="Rectangle 5"/>
-          <p:cNvSpPr/>
-          <p:nvPr/>
-        </p:nvSpPr>
-        <p:spPr>
-          <a:xfrm>
-            <a:off x="457200" y="4823460"/>
-            <a:ext cx="4572000" cy="228600"/>
-          </a:xfrm>
-          <a:prstGeom prst="rect">
-            <a:avLst/>
-          </a:prstGeom>
-          <a:noFill/>
-          <a:ln>
-            <a:noFill/>
-          </a:ln>
-          <a:effectLst/>
-        </p:spPr>
-        <p:style>
-          <a:lnRef idx="1">
-            <a:schemeClr val="accent1"/>
-          </a:lnRef>
-          <a:fillRef idx="3">
-            <a:schemeClr val="accent1"/>
-          </a:fillRef>
-          <a:effectRef idx="2">
-            <a:schemeClr val="accent1"/>
-          </a:effectRef>
-          <a:fontRef idx="minor">
-            <a:schemeClr val="lt1"/>
-          </a:fontRef>
-        </p:style>
-        <p:txBody>
-          <a:bodyPr rtlCol="0" anchor="ctr" lIns="0" tIns="0" rIns="0" bIns="0" wrap="square"/>
-          <a:lstStyle/>
-          <a:p>
-            <a:pPr algn="l">
-              <a:buNone/>
-            </a:pPr>
-            <a:r>
-              <a:rPr sz="900" b="0" i="0">
-                <a:solidFill>
-                  <a:srgbClr val="6B7280"/>
-                </a:solidFill>
-                <a:latin typeface="Arial"/>
-              </a:rPr>
-              <a:t>Forensics &amp; OSINT Advanced  -  Day 2 / 3</a:t>
-            </a:r>
-          </a:p>
-        </p:txBody>
-      </p:sp>
-      <p:sp>
-        <p:nvSpPr>
-          <p:cNvPr id="7" name="Rectangle 6"/>
-          <p:cNvSpPr/>
-          <p:nvPr/>
-        </p:nvSpPr>
-        <p:spPr>
-          <a:xfrm>
-            <a:off x="457200" y="1188720"/>
-            <a:ext cx="8229600" cy="548640"/>
-          </a:xfrm>
-          <a:prstGeom prst="rect">
-            <a:avLst/>
-          </a:prstGeom>
-          <a:noFill/>
-          <a:ln>
-            <a:noFill/>
-          </a:ln>
-          <a:effectLst/>
-        </p:spPr>
-        <p:style>
-          <a:lnRef idx="1">
-            <a:schemeClr val="accent1"/>
-          </a:lnRef>
-          <a:fillRef idx="3">
-            <a:schemeClr val="accent1"/>
-          </a:fillRef>
-          <a:effectRef idx="2">
-            <a:schemeClr val="accent1"/>
-          </a:effectRef>
-          <a:fontRef idx="minor">
-            <a:schemeClr val="lt1"/>
-          </a:fontRef>
-        </p:style>
-        <p:txBody>
-          <a:bodyPr rtlCol="0" anchor="ctr" lIns="0" tIns="0" rIns="0" bIns="0" wrap="square"/>
-          <a:lstStyle/>
-          <a:p>
-            <a:pPr algn="l">
-              <a:buNone/>
-            </a:pPr>
-            <a:r>
-              <a:rPr sz="1300" b="0" i="1">
-                <a:solidFill>
-                  <a:srgbClr val="1F2937"/>
-                </a:solidFill>
-                <a:latin typeface="Arial"/>
-              </a:rPr>
-              <a:t>A structured, sourced, auditable note - one per TP.</a:t>
-            </a:r>
-          </a:p>
-        </p:txBody>
-      </p:sp>
-      <p:sp>
-        <p:nvSpPr>
-          <p:cNvPr id="8" name="Rectangle 7"/>
-          <p:cNvSpPr/>
-          <p:nvPr/>
-        </p:nvSpPr>
-        <p:spPr>
-          <a:xfrm>
-            <a:off x="457200" y="1837360"/>
-            <a:ext cx="8229600" cy="2662640"/>
-          </a:xfrm>
-          <a:prstGeom prst="rect">
-            <a:avLst/>
-          </a:prstGeom>
-          <a:noFill/>
-          <a:ln>
-            <a:noFill/>
-          </a:ln>
-          <a:effectLst/>
-        </p:spPr>
-        <p:style>
-          <a:lnRef idx="1">
-            <a:schemeClr val="accent1"/>
-          </a:lnRef>
-          <a:fillRef idx="3">
-            <a:schemeClr val="accent1"/>
-          </a:fillRef>
-          <a:effectRef idx="2">
-            <a:schemeClr val="accent1"/>
-          </a:effectRef>
-          <a:fontRef idx="minor">
-            <a:schemeClr val="lt1"/>
-          </a:fontRef>
-        </p:style>
-        <p:txBody>
-          <a:bodyPr rtlCol="0" anchor="t" lIns="0" tIns="0" rIns="0" bIns="0" wrap="square"/>
-          <a:lstStyle/>
-          <a:p>
-            <a:pPr algn="l" marL="228600" indent="-228600">
-              <a:lnSpc>
-                <a:spcPct val="105000"/>
-              </a:lnSpc>
-              <a:spcAft>
-                <a:spcPts val="600"/>
-              </a:spcAft>
-              <a:buClr>
-                <a:srgbClr val="1E40AF"/>
-              </a:buClr>
-              <a:buFont typeface="Arial"/>
-              <a:buChar char="•"/>
-            </a:pPr>
-            <a:r>
-              <a:rPr sz="1100" b="0" i="0">
-                <a:solidFill>
-                  <a:srgbClr val="1F2937"/>
-                </a:solidFill>
-                <a:latin typeface="Arial"/>
-              </a:rPr>
-              <a:t>The finding, with its Admiralty rating (source A-F x information 1-6).</a:t>
-            </a:r>
-          </a:p>
-          <a:p>
-            <a:pPr algn="l" marL="228600" indent="-228600">
-              <a:lnSpc>
-                <a:spcPct val="105000"/>
-              </a:lnSpc>
-              <a:spcAft>
-                <a:spcPts val="600"/>
-              </a:spcAft>
-              <a:buClr>
-                <a:srgbClr val="1E40AF"/>
-              </a:buClr>
-              <a:buFont typeface="Arial"/>
-              <a:buChar char="•"/>
-            </a:pPr>
-            <a:r>
-              <a:rPr sz="1100" b="0" i="0">
-                <a:solidFill>
-                  <a:srgbClr val="1F2937"/>
-                </a:solidFill>
-                <a:latin typeface="Arial"/>
-              </a:rPr>
-              <a:t>Provenance: source URL, UTC timestamp, SHA-256 of every captured artefact (Day 1 discipline).</a:t>
-            </a:r>
-          </a:p>
-          <a:p>
-            <a:pPr algn="l" marL="228600" indent="-228600">
-              <a:lnSpc>
-                <a:spcPct val="105000"/>
-              </a:lnSpc>
-              <a:spcAft>
-                <a:spcPts val="600"/>
-              </a:spcAft>
-              <a:buClr>
-                <a:srgbClr val="1E40AF"/>
-              </a:buClr>
-              <a:buFont typeface="Arial"/>
-              <a:buChar char="•"/>
-            </a:pPr>
-            <a:r>
-              <a:rPr sz="1100" b="0" i="0">
-                <a:solidFill>
-                  <a:srgbClr val="1F2937"/>
-                </a:solidFill>
-                <a:latin typeface="Arial"/>
-              </a:rPr>
-              <a:t>Reproducible: an auditor should reach the same conclusion from your note.</a:t>
-            </a:r>
-          </a:p>
-          <a:p>
-            <a:pPr algn="l" marL="228600" indent="-228600">
-              <a:lnSpc>
-                <a:spcPct val="105000"/>
-              </a:lnSpc>
-              <a:spcAft>
-                <a:spcPts val="600"/>
-              </a:spcAft>
-              <a:buClr>
-                <a:srgbClr val="1E40AF"/>
-              </a:buClr>
-              <a:buFont typeface="Arial"/>
-              <a:buChar char="•"/>
-            </a:pPr>
-            <a:r>
-              <a:rPr sz="1100" b="0" i="0">
-                <a:solidFill>
-                  <a:srgbClr val="1F2937"/>
-                </a:solidFill>
-                <a:latin typeface="Arial"/>
-              </a:rPr>
-              <a:t>A clear, graded conclusion - confirmed / probable / possible / unverifiable.</a:t>
+              <a:t>Geolocation &amp; chronolocation. Rate every finding with the Admiralty scale.</a:t>
             </a:r>
           </a:p>
         </p:txBody>
@@ -20469,7 +20050,7 @@
                 </a:solidFill>
                 <a:latin typeface="Arial"/>
               </a:rPr>
-              <a:t>KEY TAKEAWAYS</a:t>
+              <a:t>LAB — AFTERNOON</a:t>
             </a:r>
           </a:p>
         </p:txBody>
@@ -20522,7 +20103,7 @@
                 </a:solidFill>
                 <a:latin typeface="Arial"/>
               </a:rPr>
-              <a:t>Day 2 key takeaways</a:t>
+              <a:t>Deliverable: sourced note (Admiralty)</a:t>
             </a:r>
           </a:p>
         </p:txBody>
@@ -20674,7 +20255,7 @@
                 </a:solidFill>
                 <a:latin typeface="Arial"/>
               </a:rPr>
-              <a:t>End-of-day quiz to follow.</a:t>
+              <a:t>A structured, sourced, auditable note - one per TP.</a:t>
             </a:r>
           </a:p>
         </p:txBody>
@@ -20737,7 +20318,7 @@
                 </a:solidFill>
                 <a:latin typeface="Arial"/>
               </a:rPr>
-              <a:t>A visual has no evidentiary value by default: it must be authenticated.</a:t>
+              <a:t>The finding, with its Admiralty rating (source A-F x information 1-6).</a:t>
             </a:r>
           </a:p>
           <a:p>
@@ -20761,7 +20342,7 @@
                 </a:solidFill>
                 <a:latin typeface="Arial"/>
               </a:rPr>
-              <a:t>Chain: provenance, source, date, place, motivation.</a:t>
+              <a:t>Provenance: source URL, UTC timestamp, SHA-256 of every captured artefact (Day 1 discipline).</a:t>
             </a:r>
           </a:p>
           <a:p>
@@ -20785,7 +20366,7 @@
                 </a:solidFill>
                 <a:latin typeface="Arial"/>
               </a:rPr>
-              <a:t>Metadata and ELA point the way; reason by convergence.</a:t>
+              <a:t>Reproducible: an auditor should reach the same conclusion from your note.</a:t>
             </a:r>
           </a:p>
           <a:p>
@@ -20809,253 +20390,7 @@
                 </a:solidFill>
                 <a:latin typeface="Arial"/>
               </a:rPr>
-              <a:t>Deepfakes: prioritise provenance (C2PA) and cross-checking.</a:t>
-            </a:r>
-          </a:p>
-          <a:p>
-            <a:pPr algn="l" marL="228600" indent="-228600">
-              <a:lnSpc>
-                <a:spcPct val="105000"/>
-              </a:lnSpc>
-              <a:spcAft>
-                <a:spcPts val="600"/>
-              </a:spcAft>
-              <a:buClr>
-                <a:srgbClr val="1E40AF"/>
-              </a:buClr>
-              <a:buFont typeface="Arial"/>
-              <a:buChar char="•"/>
-            </a:pPr>
-            <a:r>
-              <a:rPr sz="1100" b="0" i="0">
-                <a:solidFill>
-                  <a:srgbClr val="1F2937"/>
-                </a:solidFill>
-                <a:latin typeface="Arial"/>
-              </a:rPr>
-              <a:t>The dominant lie is recontextualisation → reverse image.</a:t>
-            </a:r>
-          </a:p>
-          <a:p>
-            <a:pPr algn="l" marL="228600" indent="-228600">
-              <a:lnSpc>
-                <a:spcPct val="105000"/>
-              </a:lnSpc>
-              <a:spcAft>
-                <a:spcPts val="600"/>
-              </a:spcAft>
-              <a:buClr>
-                <a:srgbClr val="1E40AF"/>
-              </a:buClr>
-              <a:buFont typeface="Arial"/>
-              <a:buChar char="•"/>
-            </a:pPr>
-            <a:r>
-              <a:rPr sz="1100" b="0" i="0">
-                <a:solidFill>
-                  <a:srgbClr val="1F2937"/>
-                </a:solidFill>
-                <a:latin typeface="Arial"/>
-              </a:rPr>
-              <a:t>Disinformation: isolate, source, detect CIB through network analysis.</a:t>
-            </a:r>
-          </a:p>
-        </p:txBody>
-      </p:sp>
-      <p:sp>
-        <p:nvSpPr>
-          <p:cNvPr id="9" name="Rectangle 8"/>
-          <p:cNvSpPr/>
-          <p:nvPr/>
-        </p:nvSpPr>
-        <p:spPr>
-          <a:xfrm>
-            <a:off x="457200" y="4434840"/>
-            <a:ext cx="8229600" cy="411480"/>
-          </a:xfrm>
-          <a:prstGeom prst="rect">
-            <a:avLst/>
-          </a:prstGeom>
-          <a:solidFill>
-            <a:srgbClr val="F3F4F6"/>
-          </a:solidFill>
-          <a:ln w="12700">
-            <a:solidFill>
-              <a:srgbClr val="F3F4F6"/>
-            </a:solidFill>
-          </a:ln>
-          <a:effectLst/>
-        </p:spPr>
-        <p:style>
-          <a:lnRef idx="1">
-            <a:schemeClr val="accent1"/>
-          </a:lnRef>
-          <a:fillRef idx="3">
-            <a:schemeClr val="accent1"/>
-          </a:fillRef>
-          <a:effectRef idx="2">
-            <a:schemeClr val="accent1"/>
-          </a:effectRef>
-          <a:fontRef idx="minor">
-            <a:schemeClr val="lt1"/>
-          </a:fontRef>
-        </p:style>
-        <p:txBody>
-          <a:bodyPr rtlCol="0" anchor="ctr"/>
-          <a:lstStyle/>
-          <a:p>
-            <a:pPr algn="ctr"/>
-          </a:p>
-        </p:txBody>
-      </p:sp>
-      <p:sp>
-        <p:nvSpPr>
-          <p:cNvPr id="10" name="Rectangle 9"/>
-          <p:cNvSpPr/>
-          <p:nvPr/>
-        </p:nvSpPr>
-        <p:spPr>
-          <a:xfrm>
-            <a:off x="457200" y="4434840"/>
-            <a:ext cx="73152" cy="411480"/>
-          </a:xfrm>
-          <a:prstGeom prst="rect">
-            <a:avLst/>
-          </a:prstGeom>
-          <a:solidFill>
-            <a:srgbClr val="15803D"/>
-          </a:solidFill>
-          <a:ln w="12700">
-            <a:solidFill>
-              <a:srgbClr val="15803D"/>
-            </a:solidFill>
-          </a:ln>
-          <a:effectLst/>
-        </p:spPr>
-        <p:style>
-          <a:lnRef idx="1">
-            <a:schemeClr val="accent1"/>
-          </a:lnRef>
-          <a:fillRef idx="3">
-            <a:schemeClr val="accent1"/>
-          </a:fillRef>
-          <a:effectRef idx="2">
-            <a:schemeClr val="accent1"/>
-          </a:effectRef>
-          <a:fontRef idx="minor">
-            <a:schemeClr val="lt1"/>
-          </a:fontRef>
-        </p:style>
-        <p:txBody>
-          <a:bodyPr rtlCol="0" anchor="ctr"/>
-          <a:lstStyle/>
-          <a:p>
-            <a:pPr algn="ctr"/>
-          </a:p>
-        </p:txBody>
-      </p:sp>
-      <p:sp>
-        <p:nvSpPr>
-          <p:cNvPr id="11" name="Rectangle 10"/>
-          <p:cNvSpPr/>
-          <p:nvPr/>
-        </p:nvSpPr>
-        <p:spPr>
-          <a:xfrm>
-            <a:off x="640080" y="4464840"/>
-            <a:ext cx="7955280" cy="200000"/>
-          </a:xfrm>
-          <a:prstGeom prst="rect">
-            <a:avLst/>
-          </a:prstGeom>
-          <a:noFill/>
-          <a:ln>
-            <a:noFill/>
-          </a:ln>
-          <a:effectLst/>
-        </p:spPr>
-        <p:style>
-          <a:lnRef idx="1">
-            <a:schemeClr val="accent1"/>
-          </a:lnRef>
-          <a:fillRef idx="3">
-            <a:schemeClr val="accent1"/>
-          </a:fillRef>
-          <a:effectRef idx="2">
-            <a:schemeClr val="accent1"/>
-          </a:effectRef>
-          <a:fontRef idx="minor">
-            <a:schemeClr val="lt1"/>
-          </a:fontRef>
-        </p:style>
-        <p:txBody>
-          <a:bodyPr rtlCol="0" anchor="ctr" lIns="0" tIns="0" rIns="0" bIns="0" wrap="square"/>
-          <a:lstStyle/>
-          <a:p>
-            <a:pPr algn="l">
-              <a:buNone/>
-            </a:pPr>
-            <a:r>
-              <a:rPr sz="1000" b="1" i="0">
-                <a:solidFill>
-                  <a:srgbClr val="15803D"/>
-                </a:solidFill>
-                <a:latin typeface="Arial"/>
-              </a:rPr>
-              <a:t>NEXT</a:t>
-            </a:r>
-          </a:p>
-        </p:txBody>
-      </p:sp>
-      <p:sp>
-        <p:nvSpPr>
-          <p:cNvPr id="12" name="Rectangle 11"/>
-          <p:cNvSpPr/>
-          <p:nvPr/>
-        </p:nvSpPr>
-        <p:spPr>
-          <a:xfrm>
-            <a:off x="640080" y="4644840"/>
-            <a:ext cx="7955280" cy="190000"/>
-          </a:xfrm>
-          <a:prstGeom prst="rect">
-            <a:avLst/>
-          </a:prstGeom>
-          <a:noFill/>
-          <a:ln>
-            <a:noFill/>
-          </a:ln>
-          <a:effectLst/>
-        </p:spPr>
-        <p:style>
-          <a:lnRef idx="1">
-            <a:schemeClr val="accent1"/>
-          </a:lnRef>
-          <a:fillRef idx="3">
-            <a:schemeClr val="accent1"/>
-          </a:fillRef>
-          <a:effectRef idx="2">
-            <a:schemeClr val="accent1"/>
-          </a:effectRef>
-          <a:fontRef idx="minor">
-            <a:schemeClr val="lt1"/>
-          </a:fontRef>
-        </p:style>
-        <p:txBody>
-          <a:bodyPr rtlCol="0" anchor="t" lIns="0" tIns="0" rIns="0" bIns="0" wrap="square"/>
-          <a:lstStyle/>
-          <a:p>
-            <a:pPr algn="l">
-              <a:buNone/>
-            </a:pPr>
-            <a:r>
-              <a:rPr sz="1000" b="0" i="0">
-                <a:solidFill>
-                  <a:srgbClr val="1F2937"/>
-                </a:solidFill>
-                <a:latin typeface="Arial"/>
-              </a:rPr>
-              <a:t>Day 3 — Dark web, crypto tracing &amp; endpoint forensics (memory analysis).</a:t>
+              <a:t>A clear, graded conclusion - confirmed / probable / possible / unverifiable.</a:t>
             </a:r>
           </a:p>
         </p:txBody>
@@ -21150,7 +20485,7 @@
                 </a:solidFill>
                 <a:latin typeface="Arial"/>
               </a:rPr>
-              <a:t>LAB - TP 2</a:t>
+              <a:t>KEY TAKEAWAYS</a:t>
             </a:r>
           </a:p>
         </p:txBody>
@@ -21203,7 +20538,7 @@
                 </a:solidFill>
                 <a:latin typeface="Arial"/>
               </a:rPr>
-              <a:t>API Scraping - intercept &amp; replay</a:t>
+              <a:t>Day 2 key takeaways</a:t>
             </a:r>
           </a:p>
         </p:txBody>
@@ -21355,7 +20690,7 @@
                 </a:solidFill>
                 <a:latin typeface="Arial"/>
               </a:rPr>
-              <a:t>Capture the real session in Burp, find the product/stock endpoint, then scale it in Python.</a:t>
+              <a:t>End-of-day quiz to follow.</a:t>
             </a:r>
           </a:p>
         </p:txBody>
@@ -21368,54 +20703,8 @@
         </p:nvSpPr>
         <p:spPr>
           <a:xfrm>
-            <a:off x="457200" y="1828800"/>
-            <a:ext cx="8229600" cy="2360000"/>
-          </a:xfrm>
-          <a:prstGeom prst="rect">
-            <a:avLst/>
-          </a:prstGeom>
-          <a:solidFill>
-            <a:srgbClr val="F9FAFB"/>
-          </a:solidFill>
-          <a:ln w="6350">
-            <a:solidFill>
-              <a:srgbClr val="E5E7EB"/>
-            </a:solidFill>
-          </a:ln>
-          <a:effectLst/>
-        </p:spPr>
-        <p:style>
-          <a:lnRef idx="1">
-            <a:schemeClr val="accent1"/>
-          </a:lnRef>
-          <a:fillRef idx="3">
-            <a:schemeClr val="accent1"/>
-          </a:fillRef>
-          <a:effectRef idx="2">
-            <a:schemeClr val="accent1"/>
-          </a:effectRef>
-          <a:fontRef idx="minor">
-            <a:schemeClr val="lt1"/>
-          </a:fontRef>
-        </p:style>
-        <p:txBody>
-          <a:bodyPr rtlCol="0" anchor="ctr"/>
-          <a:lstStyle/>
-          <a:p>
-            <a:pPr algn="ctr"/>
-          </a:p>
-        </p:txBody>
-      </p:sp>
-      <p:sp>
-        <p:nvSpPr>
-          <p:cNvPr id="9" name="Rectangle 8"/>
-          <p:cNvSpPr/>
-          <p:nvPr/>
-        </p:nvSpPr>
-        <p:spPr>
-          <a:xfrm>
-            <a:off x="594360" y="1920240"/>
-            <a:ext cx="7955280" cy="2177120"/>
+            <a:off x="457200" y="1837360"/>
+            <a:ext cx="8229600" cy="2662640"/>
           </a:xfrm>
           <a:prstGeom prst="rect">
             <a:avLst/>
@@ -21444,146 +20733,154 @@
           <a:bodyPr rtlCol="0" anchor="t" lIns="0" tIns="0" rIns="0" bIns="0" wrap="square"/>
           <a:lstStyle/>
           <a:p>
-            <a:pPr algn="l">
+            <a:pPr algn="l" marL="228600" indent="-228600">
               <a:lnSpc>
-                <a:spcPct val="102000"/>
+                <a:spcPct val="105000"/>
               </a:lnSpc>
-              <a:buNone/>
-            </a:pPr>
-            <a:r>
-              <a:rPr sz="1050" b="0" i="0">
-                <a:solidFill>
-                  <a:srgbClr val="6B7280"/>
-                </a:solidFill>
-                <a:latin typeface="Consolas"/>
-              </a:rPr>
-              <a:t># 1) Burp: browse the site, find the product endpoint in HTTP history</a:t>
-            </a:r>
-          </a:p>
-          <a:p>
-            <a:pPr algn="l">
+              <a:spcAft>
+                <a:spcPts val="600"/>
+              </a:spcAft>
+              <a:buClr>
+                <a:srgbClr val="1E40AF"/>
+              </a:buClr>
+              <a:buFont typeface="Arial"/>
+              <a:buChar char="•"/>
+            </a:pPr>
+            <a:r>
+              <a:rPr sz="1100" b="0" i="0">
+                <a:solidFill>
+                  <a:srgbClr val="1F2937"/>
+                </a:solidFill>
+                <a:latin typeface="Arial"/>
+              </a:rPr>
+              <a:t>A visual has no evidentiary value by default: it must be authenticated.</a:t>
+            </a:r>
+          </a:p>
+          <a:p>
+            <a:pPr algn="l" marL="228600" indent="-228600">
               <a:lnSpc>
-                <a:spcPct val="102000"/>
+                <a:spcPct val="105000"/>
               </a:lnSpc>
-              <a:buNone/>
-            </a:pPr>
-            <a:r>
-              <a:rPr sz="1050" b="0" i="0">
-                <a:solidFill>
-                  <a:srgbClr val="6B7280"/>
-                </a:solidFill>
-                <a:latin typeface="Consolas"/>
-              </a:rPr>
-              <a:t># 2) read its request: params (pagination), Authorization: Bearer, cookies</a:t>
-            </a:r>
-          </a:p>
-          <a:p>
-            <a:pPr algn="l">
+              <a:spcAft>
+                <a:spcPts val="600"/>
+              </a:spcAft>
+              <a:buClr>
+                <a:srgbClr val="1E40AF"/>
+              </a:buClr>
+              <a:buFont typeface="Arial"/>
+              <a:buChar char="•"/>
+            </a:pPr>
+            <a:r>
+              <a:rPr sz="1100" b="0" i="0">
+                <a:solidFill>
+                  <a:srgbClr val="1F2937"/>
+                </a:solidFill>
+                <a:latin typeface="Arial"/>
+              </a:rPr>
+              <a:t>Chain: provenance, source, date, place, motivation.</a:t>
+            </a:r>
+          </a:p>
+          <a:p>
+            <a:pPr algn="l" marL="228600" indent="-228600">
               <a:lnSpc>
-                <a:spcPct val="102000"/>
+                <a:spcPct val="105000"/>
               </a:lnSpc>
-              <a:buNone/>
-            </a:pPr>
-            <a:r>
-              <a:rPr sz="1050" b="0" i="0">
-                <a:solidFill>
-                  <a:srgbClr val="6B7280"/>
-                </a:solidFill>
-                <a:latin typeface="Consolas"/>
-              </a:rPr>
-              <a:t># 3) replay &amp; paginate it in Python (requests)</a:t>
-            </a:r>
-          </a:p>
-          <a:p>
-            <a:pPr algn="l">
+              <a:spcAft>
+                <a:spcPts val="600"/>
+              </a:spcAft>
+              <a:buClr>
+                <a:srgbClr val="1E40AF"/>
+              </a:buClr>
+              <a:buFont typeface="Arial"/>
+              <a:buChar char="•"/>
+            </a:pPr>
+            <a:r>
+              <a:rPr sz="1100" b="0" i="0">
+                <a:solidFill>
+                  <a:srgbClr val="1F2937"/>
+                </a:solidFill>
+                <a:latin typeface="Arial"/>
+              </a:rPr>
+              <a:t>Metadata and ELA point the way; reason by convergence.</a:t>
+            </a:r>
+          </a:p>
+          <a:p>
+            <a:pPr algn="l" marL="228600" indent="-228600">
               <a:lnSpc>
-                <a:spcPct val="102000"/>
+                <a:spcPct val="105000"/>
               </a:lnSpc>
-              <a:buNone/>
-            </a:pPr>
-            <a:r>
-              <a:rPr sz="1050" b="0" i="0">
+              <a:spcAft>
+                <a:spcPts val="600"/>
+              </a:spcAft>
+              <a:buClr>
+                <a:srgbClr val="1E40AF"/>
+              </a:buClr>
+              <a:buFont typeface="Arial"/>
+              <a:buChar char="•"/>
+            </a:pPr>
+            <a:r>
+              <a:rPr sz="1100" b="0" i="0">
                 <a:solidFill>
                   <a:srgbClr val="1F2937"/>
                 </a:solidFill>
-                <a:latin typeface="Consolas"/>
-              </a:rPr>
-              <a:t>s = requests.Session(); s.headers["Authorization"] = f"Bearer {token}"</a:t>
-            </a:r>
-          </a:p>
-          <a:p>
-            <a:pPr algn="l">
+                <a:latin typeface="Arial"/>
+              </a:rPr>
+              <a:t>Deepfakes: prioritise provenance (C2PA) and cross-checking.</a:t>
+            </a:r>
+          </a:p>
+          <a:p>
+            <a:pPr algn="l" marL="228600" indent="-228600">
               <a:lnSpc>
-                <a:spcPct val="102000"/>
+                <a:spcPct val="105000"/>
               </a:lnSpc>
-              <a:buNone/>
-            </a:pPr>
-            <a:r>
-              <a:rPr sz="1050" b="0" i="0">
+              <a:spcAft>
+                <a:spcPts val="600"/>
+              </a:spcAft>
+              <a:buClr>
+                <a:srgbClr val="1E40AF"/>
+              </a:buClr>
+              <a:buFont typeface="Arial"/>
+              <a:buChar char="•"/>
+            </a:pPr>
+            <a:r>
+              <a:rPr sz="1100" b="0" i="0">
                 <a:solidFill>
                   <a:srgbClr val="1F2937"/>
                 </a:solidFill>
-                <a:latin typeface="Consolas"/>
-              </a:rPr>
-              <a:t>while start &lt; total:</a:t>
-            </a:r>
-          </a:p>
-          <a:p>
-            <a:pPr algn="l">
+                <a:latin typeface="Arial"/>
+              </a:rPr>
+              <a:t>The dominant lie is recontextualisation → reverse image.</a:t>
+            </a:r>
+          </a:p>
+          <a:p>
+            <a:pPr algn="l" marL="228600" indent="-228600">
               <a:lnSpc>
-                <a:spcPct val="102000"/>
+                <a:spcPct val="105000"/>
               </a:lnSpc>
-              <a:buNone/>
-            </a:pPr>
-            <a:r>
-              <a:rPr sz="1050" b="0" i="0">
+              <a:spcAft>
+                <a:spcPts val="600"/>
+              </a:spcAft>
+              <a:buClr>
+                <a:srgbClr val="1E40AF"/>
+              </a:buClr>
+              <a:buFont typeface="Arial"/>
+              <a:buChar char="•"/>
+            </a:pPr>
+            <a:r>
+              <a:rPr sz="1100" b="0" i="0">
                 <a:solidFill>
                   <a:srgbClr val="1F2937"/>
                 </a:solidFill>
-                <a:latin typeface="Consolas"/>
-              </a:rPr>
-              <a:t>    hits += s.get(url, params={"c_start": start, "c_sz": 48}).json()["hits"]</a:t>
-            </a:r>
-          </a:p>
-          <a:p>
-            <a:pPr algn="l">
-              <a:lnSpc>
-                <a:spcPct val="102000"/>
-              </a:lnSpc>
-              <a:buNone/>
-            </a:pPr>
-            <a:r>
-              <a:rPr sz="1050" b="0" i="0">
-                <a:solidFill>
-                  <a:srgbClr val="1F2937"/>
-                </a:solidFill>
-                <a:latin typeface="Consolas"/>
-              </a:rPr>
-              <a:t>    start += 48</a:t>
-            </a:r>
-          </a:p>
-          <a:p>
-            <a:pPr algn="l">
-              <a:lnSpc>
-                <a:spcPct val="102000"/>
-              </a:lnSpc>
-              <a:buNone/>
-            </a:pPr>
-            <a:r>
-              <a:rPr sz="1050" b="0" i="0">
-                <a:solidFill>
-                  <a:srgbClr val="1F2937"/>
-                </a:solidFill>
-                <a:latin typeface="Consolas"/>
-              </a:rPr>
-              <a:t>pd.json_normalize(hits).to_csv("products.csv", index=False)</a:t>
-            </a:r>
-          </a:p>
-        </p:txBody>
-      </p:sp>
-      <p:sp>
-        <p:nvSpPr>
-          <p:cNvPr id="10" name="Rectangle 9"/>
+                <a:latin typeface="Arial"/>
+              </a:rPr>
+              <a:t>Disinformation: isolate, source, detect CIB through network analysis.</a:t>
+            </a:r>
+          </a:p>
+        </p:txBody>
+      </p:sp>
+      <p:sp>
+        <p:nvSpPr>
+          <p:cNvPr id="9" name="Rectangle 8"/>
           <p:cNvSpPr/>
           <p:nvPr/>
         </p:nvSpPr>
@@ -21629,7 +20926,7 @@
       </p:sp>
       <p:sp>
         <p:nvSpPr>
-          <p:cNvPr id="11" name="Rectangle 10"/>
+          <p:cNvPr id="10" name="Rectangle 9"/>
           <p:cNvSpPr/>
           <p:nvPr/>
         </p:nvSpPr>
@@ -21642,11 +20939,11 @@
             <a:avLst/>
           </a:prstGeom>
           <a:solidFill>
-            <a:srgbClr val="B45309"/>
+            <a:srgbClr val="15803D"/>
           </a:solidFill>
           <a:ln w="12700">
             <a:solidFill>
-              <a:srgbClr val="B45309"/>
+              <a:srgbClr val="15803D"/>
             </a:solidFill>
           </a:ln>
           <a:effectLst/>
@@ -21675,7 +20972,7 @@
       </p:sp>
       <p:sp>
         <p:nvSpPr>
-          <p:cNvPr id="12" name="Rectangle 11"/>
+          <p:cNvPr id="11" name="Rectangle 10"/>
           <p:cNvSpPr/>
           <p:nvPr/>
         </p:nvSpPr>
@@ -21717,18 +21014,18 @@
             <a:r>
               <a:rPr sz="1000" b="1" i="0">
                 <a:solidFill>
-                  <a:srgbClr val="B45309"/>
-                </a:solidFill>
-                <a:latin typeface="Arial"/>
-              </a:rPr>
-              <a:t>METHOD</a:t>
-            </a:r>
-          </a:p>
-        </p:txBody>
-      </p:sp>
-      <p:sp>
-        <p:nvSpPr>
-          <p:cNvPr id="13" name="Rectangle 12"/>
+                  <a:srgbClr val="15803D"/>
+                </a:solidFill>
+                <a:latin typeface="Arial"/>
+              </a:rPr>
+              <a:t>NEXT</a:t>
+            </a:r>
+          </a:p>
+        </p:txBody>
+      </p:sp>
+      <p:sp>
+        <p:nvSpPr>
+          <p:cNvPr id="12" name="Rectangle 11"/>
           <p:cNvSpPr/>
           <p:nvPr/>
         </p:nvSpPr>
@@ -21774,7 +21071,7 @@
                 </a:solidFill>
                 <a:latin typeface="Arial"/>
               </a:rPr>
-              <a:t>Burp to capture, Python to scale. Same steps for an API found via Shodan (authorised only).</a:t>
+              <a:t>Day 3 — Dark web, crypto tracing &amp; endpoint forensics (memory analysis).</a:t>
             </a:r>
           </a:p>
         </p:txBody>

</xml_diff>